<commit_message>
Revise deck: natural phrasing, README-accurate architecture diagram
- removed em dashes throughout, rewrote around them
- architecture slide now mirrors the README's Mermaid flowchart
  (Evaluate Rules / Already Notified? decision branches, Skip,
  dashed dedup lookup into the Alert State Store) instead of the
  earlier simplified linear box diagram
- removed per-person task attribution from the repo slide and
  dropped the status/next-steps slide until the new ServiceNow
  instance is live
</commit_message>
<xml_diff>
--- a/n8n-epsilon-detailed.pptx
+++ b/n8n-epsilon-detailed.pptx
@@ -21,10 +21,9 @@
     <p:sldId id="269" r:id="rId15"/>
     <p:sldId id="270" r:id="rId16"/>
     <p:sldId id="271" r:id="rId17"/>
-    <p:sldId id="272" r:id="rId18"/>
   </p:sldIdLst>
   <p:notesMasterIdLst>
-    <p:notesMasterId r:id="rId19"/>
+    <p:notesMasterId r:id="rId18"/>
   </p:notesMasterIdLst>
   <p:sldSz cx="12192000" cy="6858000"/>
   <p:notesSz cx="6858000" cy="12192000"/>
@@ -123,34 +122,34 @@
   <p:extLst>
     <p:ext uri="{521415D9-36F7-43E2-AB2F-B90AF26B5E84}">
       <p14:sectionLst xmlns:p14="http://schemas.microsoft.com/office/powerpoint/2010/main">
-        <p14:section name="Title" id="{1819c7f5-bc89-5463-2b25-199a4ebb9c22}">
+        <p14:section name="Title" id="{79bef504-c25c-d523-ce70-fb699dab4941}">
           <p14:sldIdLst>
             <p14:sldId id="256"/>
           </p14:sldIdLst>
         </p14:section>
-        <p14:section name="Overview" id="{7e1473d0-e326-cb20-fc18-408d0ddd8cad}">
+        <p14:section name="Overview" id="{674ff281-ff4e-f735-9162-42788e9e337b}">
           <p14:sldIdLst>
             <p14:sldId id="257"/>
             <p14:sldId id="258"/>
           </p14:sldIdLst>
         </p14:section>
-        <p14:section name="Architecture" id="{ffcbe2b7-a026-c210-bb7d-237cdeac39b1}">
+        <p14:section name="Architecture" id="{6ab84a24-34bb-a220-5380-67002fb7715e}">
           <p14:sldIdLst>
             <p14:sldId id="259"/>
             <p14:sldId id="260"/>
           </p14:sldIdLst>
         </p14:section>
-        <p14:section name="Logic" id="{f09171c5-154f-6aed-d1aa-f924bb488615}">
+        <p14:section name="Logic" id="{77511e09-5c96-a583-5172-29b040438071}">
           <p14:sldIdLst>
             <p14:sldId id="261"/>
           </p14:sldIdLst>
         </p14:section>
-        <p14:section name="Pipeline" id="{ae95dfdd-dbfb-15ad-b82e-8ac06b111c6e}">
+        <p14:section name="Pipeline" id="{480717bc-cc4b-f816-00bf-35be864b09ea}">
           <p14:sldIdLst>
             <p14:sldId id="262"/>
           </p14:sldIdLst>
         </p14:section>
-        <p14:section name="Reliability" id="{5231954d-7539-f912-4445-e7578415b34d}">
+        <p14:section name="Reliability" id="{545f2a04-1370-964a-d7b5-e93f33405250}">
           <p14:sldIdLst>
             <p14:sldId id="263"/>
             <p14:sldId id="264"/>
@@ -160,16 +159,11 @@
             <p14:sldId id="268"/>
           </p14:sldIdLst>
         </p14:section>
-        <p14:section name="Delivery" id="{ecd6551d-bae9-decc-3c6b-1b066dd13355}">
+        <p14:section name="Delivery" id="{1c02ff88-90c6-4db7-ce90-3dd9a93e27e9}">
           <p14:sldIdLst>
             <p14:sldId id="269"/>
             <p14:sldId id="270"/>
             <p14:sldId id="271"/>
-          </p14:sldIdLst>
-        </p14:section>
-        <p14:section name="Status" id="{c869a52f-7927-cbaf-e265-10f9572deff4}">
-          <p14:sldIdLst>
-            <p14:sldId id="272"/>
           </p14:sldIdLst>
         </p14:section>
       </p14:sectionLst>
@@ -1216,94 +1210,6 @@
             <a:fld id="{F7021451-1387-4CA6-816F-3879F97B5CBC}" type="slidenum">
               <a:rPr lang="en-US"/>
               <a:t>16</a:t>
-            </a:fld>
-            <a:endParaRPr lang="en-US"/>
-          </a:p>
-        </p:txBody>
-      </p:sp>
-    </p:spTree>
-    <p:extLst>
-      <p:ext uri="{BB962C8B-B14F-4D97-AF65-F5344CB8AC3E}">
-        <p14:creationId xmlns:p14="http://schemas.microsoft.com/office/powerpoint/2010/main" val="1024086991"/>
-      </p:ext>
-    </p:extLst>
-  </p:cSld>
-  <p:clrMapOvr>
-    <a:masterClrMapping/>
-  </p:clrMapOvr>
-</p:notes>
-</file>
-
-<file path=ppt/notesSlides/notesSlide17.xml><?xml version="1.0" encoding="utf-8"?>
-<p:notes xmlns:a="http://schemas.openxmlformats.org/drawingml/2006/main" xmlns:r="http://schemas.openxmlformats.org/officeDocument/2006/relationships" xmlns:p="http://schemas.openxmlformats.org/presentationml/2006/main">
-  <p:cSld>
-    <p:spTree>
-      <p:nvGrpSpPr>
-        <p:cNvPr id="1" name=""/>
-        <p:cNvGrpSpPr/>
-        <p:nvPr/>
-      </p:nvGrpSpPr>
-      <p:grpSpPr>
-        <a:xfrm>
-          <a:off x="0" y="0"/>
-          <a:ext cx="0" cy="0"/>
-          <a:chOff x="0" y="0"/>
-          <a:chExt cx="0" cy="0"/>
-        </a:xfrm>
-      </p:grpSpPr>
-      <p:sp>
-        <p:nvSpPr>
-          <p:cNvPr id="2" name="Slide Image Placeholder 1"/>
-          <p:cNvSpPr>
-            <a:spLocks noGrp="1" noRot="1" noChangeAspect="1"/>
-          </p:cNvSpPr>
-          <p:nvPr>
-            <p:ph type="sldImg"/>
-          </p:nvPr>
-        </p:nvSpPr>
-        <p:spPr/>
-      </p:sp>
-      <p:sp>
-        <p:nvSpPr>
-          <p:cNvPr id="3" name="Notes Placeholder 2"/>
-          <p:cNvSpPr>
-            <a:spLocks noGrp="1"/>
-          </p:cNvSpPr>
-          <p:nvPr>
-            <p:ph type="body" idx="1"/>
-          </p:nvPr>
-        </p:nvSpPr>
-        <p:spPr/>
-        <p:txBody>
-          <a:bodyPr/>
-          <a:lstStyle/>
-          <a:p>
-            <a:r>
-              <a:rPr lang="en-US" dirty="0"/>
-              <a:t/>
-            </a:r>
-            <a:endParaRPr lang="en-US" dirty="0"/>
-          </a:p>
-        </p:txBody>
-      </p:sp>
-      <p:sp>
-        <p:nvSpPr>
-          <p:cNvPr id="4" name="Slide Number Placeholder 3"/>
-          <p:cNvSpPr>
-            <a:spLocks noGrp="1"/>
-          </p:cNvSpPr>
-          <p:nvPr>
-            <p:ph type="sldNum" sz="quarter" idx="10"/>
-          </p:nvPr>
-        </p:nvSpPr>
-        <p:spPr/>
-        <p:txBody>
-          <a:bodyPr/>
-          <a:lstStyle/>
-          <a:p>
-            <a:fld id="{F7021451-1387-4CA6-816F-3879F97B5CBC}" type="slidenum">
-              <a:rPr lang="en-US"/>
-              <a:t>17</a:t>
             </a:fld>
             <a:endParaRPr lang="en-US"/>
           </a:p>
@@ -3627,7 +3533,7 @@
                 <a:ea typeface="Courier New" pitchFamily="34" charset="-122"/>
                 <a:cs typeface="Courier New" pitchFamily="34" charset="-120"/>
               </a:rPr>
-              <a:t>// lookup.js — is this key eligible to send?</a:t>
+              <a:t>// lookup.js: is this key eligible to send?</a:t>
             </a:r>
             <a:endParaRPr lang="en-US" sz="1300" dirty="0"/>
           </a:p>
@@ -3880,7 +3786,7 @@
                 <a:ea typeface="Calibri" pitchFamily="34" charset="-122"/>
                 <a:cs typeface="Calibri" pitchFamily="34" charset="-120"/>
               </a:rPr>
-              <a:t>claim.js — written before the send</a:t>
+              <a:t>claim.js: written before the send</a:t>
             </a:r>
             <a:endParaRPr lang="en-US" sz="1300" dirty="0"/>
           </a:p>
@@ -3961,7 +3867,7 @@
                 <a:ea typeface="Calibri" pitchFamily="34" charset="-122"/>
                 <a:cs typeface="Calibri" pitchFamily="34" charset="-120"/>
               </a:rPr>
-              <a:t>This record is what survives a crash — the next run finds it, not silence.</a:t>
+              <a:t>This record is what survives a crash. The next run finds it, not silence.</a:t>
             </a:r>
             <a:endParaRPr lang="en-US" sz="1200" dirty="0"/>
           </a:p>
@@ -4094,7 +4000,7 @@
                 <a:ea typeface="Calibri" pitchFamily="34" charset="-122"/>
                 <a:cs typeface="Calibri" pitchFamily="34" charset="-120"/>
               </a:rPr>
-              <a:t> — a “pending” older than 10 min is reset to retryable.</a:t>
+              <a:t>: a “pending” older than 10 min is reset to retryable.</a:t>
             </a:r>
             <a:endParaRPr lang="en-US" sz="1200" dirty="0"/>
           </a:p>
@@ -4132,7 +4038,7 @@
                 <a:ea typeface="Calibri" pitchFamily="34" charset="-122"/>
                 <a:cs typeface="Calibri" pitchFamily="34" charset="-120"/>
               </a:rPr>
-              <a:t> — a TTL lock stops two runs from racing to claim the same key.</a:t>
+              <a:t>: a TTL lock stops two runs from racing to claim the same key.</a:t>
             </a:r>
             <a:endParaRPr lang="en-US" sz="1200" dirty="0"/>
           </a:p>
@@ -4174,7 +4080,7 @@
                 <a:ea typeface="Calibri" pitchFamily="34" charset="-122"/>
                 <a:cs typeface="Calibri" pitchFamily="34" charset="-120"/>
               </a:rPr>
-              <a:t>At-least-once delivery: a narrow-window duplicate is possible; a missed critical alert is not. Plain SMTP can't guarantee exactly-once — this is the right tradeoff.</a:t>
+              <a:t>At-least-once delivery: a narrow-window duplicate is possible; a missed critical alert is not. Plain SMTP can't guarantee exactly-once. This is the right tradeoff.</a:t>
             </a:r>
             <a:endParaRPr lang="en-US" sz="1150" dirty="0"/>
           </a:p>
@@ -4913,7 +4819,7 @@
                           <a:ea typeface="Calibri" pitchFamily="34" charset="-122"/>
                           <a:cs typeface="Calibri" pitchFamily="34" charset="-120"/>
                         </a:rPr>
-                        <a:t>Wait — reminder interval (10 min) hasn't elapsed.</a:t>
+                        <a:t>Wait: reminder interval (10 min) hasn't elapsed.</a:t>
                       </a:r>
                       <a:endParaRPr lang="en-US" sz="1350" dirty="0">
                         <a:latin typeface="Calibri" charset="0"/>
@@ -5430,7 +5336,7 @@
                 <a:ea typeface="Calibri" pitchFamily="34" charset="-122"/>
                 <a:cs typeface="Calibri" pitchFamily="34" charset="-120"/>
               </a:rPr>
-              <a:t> back to unsent on every run — only </a:t>
+              <a:t> back to unsent on every run; only </a:t>
             </a:r>
             <a:pPr algn="l" indent="0" marL="0">
               <a:lnSpc>
@@ -6922,7 +6828,7 @@
                 <a:ea typeface="Calibri" pitchFamily="34" charset="-122"/>
                 <a:cs typeface="Calibri" pitchFamily="34" charset="-120"/>
               </a:rPr>
-              <a:t>Kept in n8n workflow static data — persists across restarts on an active (production) workflow, but only saved by real scheduled runs, not manual test runs.</a:t>
+              <a:t>Kept in n8n workflow static data, persists across restarts on an active (production) workflow, but only saved by real scheduled runs, not manual test runs.</a:t>
             </a:r>
             <a:endParaRPr lang="en-US" sz="1250" dirty="0"/>
           </a:p>
@@ -7172,7 +7078,7 @@
                 <a:ea typeface="Calibri" pitchFamily="34" charset="-122"/>
                 <a:cs typeface="Calibri" pitchFamily="34" charset="-120"/>
               </a:rPr>
-              <a:t>[CRITICAL INCIDENT]  INC0010042 — Production application unavailable</a:t>
+              <a:t>[CRITICAL INCIDENT]  INC0010042 - Production application unavailable</a:t>
             </a:r>
             <a:endParaRPr lang="en-US" sz="1400" dirty="0"/>
           </a:p>
@@ -7292,7 +7198,7 @@
                 <a:ea typeface="Courier New" pitchFamily="34" charset="-122"/>
                 <a:cs typeface="Courier New" pitchFamily="34" charset="-120"/>
               </a:rPr>
-              <a:t>  Priority:       1 — Critical</a:t>
+              <a:t>  Priority:       1 - Critical</a:t>
             </a:r>
             <a:endParaRPr lang="en-US" sz="1300" dirty="0"/>
           </a:p>
@@ -7572,7 +7478,7 @@
                 <a:ea typeface="Calibri" pitchFamily="34" charset="-122"/>
                 <a:cs typeface="Calibri" pitchFamily="34" charset="-120"/>
               </a:rPr>
-              <a:t>02  —  TESTING &amp; DELIVERY</a:t>
+              <a:t>02 · TESTING &amp; DELIVERY</a:t>
             </a:r>
             <a:endParaRPr lang="en-US" sz="1400" dirty="0"/>
           </a:p>
@@ -7834,7 +7740,7 @@
                 <a:ea typeface="Cambria" pitchFamily="34" charset="-122"/>
                 <a:cs typeface="Cambria" pitchFamily="34" charset="-120"/>
               </a:rPr>
-              <a:t>Unit tests — 13/13 passing</a:t>
+              <a:t>Unit tests: 13/13 passing</a:t>
             </a:r>
             <a:endParaRPr lang="en-US" sz="1500" dirty="0"/>
           </a:p>
@@ -7880,7 +7786,7 @@
                 <a:ea typeface="Calibri" pitchFamily="34" charset="-122"/>
                 <a:cs typeface="Calibri" pitchFamily="34" charset="-120"/>
               </a:rPr>
-              <a:t>Rule logic — critical / high / stale / resolved classification</a:t>
+              <a:t>Rule logic: critical / high / stale / resolved classification</a:t>
             </a:r>
             <a:endParaRPr lang="en-US" sz="1150" dirty="0"/>
           </a:p>
@@ -7904,7 +7810,7 @@
                 <a:ea typeface="Calibri" pitchFamily="34" charset="-122"/>
                 <a:cs typeface="Calibri" pitchFamily="34" charset="-120"/>
               </a:rPr>
-              <a:t>Run lock — blocks within TTL, allows after expiry</a:t>
+              <a:t>Run lock: blocks within TTL, allows after expiry</a:t>
             </a:r>
             <a:endParaRPr lang="en-US" sz="1150" dirty="0"/>
           </a:p>
@@ -7928,7 +7834,7 @@
                 <a:ea typeface="Calibri" pitchFamily="34" charset="-122"/>
                 <a:cs typeface="Calibri" pitchFamily="34" charset="-120"/>
               </a:rPr>
-              <a:t>Stale-claim recovery — abandoned claims reset to retryable</a:t>
+              <a:t>Stale-claim recovery: abandoned claims reset to retryable</a:t>
             </a:r>
             <a:endParaRPr lang="en-US" sz="1150" dirty="0"/>
           </a:p>
@@ -7952,7 +7858,7 @@
                 <a:ea typeface="Calibri" pitchFamily="34" charset="-122"/>
                 <a:cs typeface="Calibri" pitchFamily="34" charset="-120"/>
               </a:rPr>
-              <a:t>Lookup — skip, retry, reminder-due, and reopen cases</a:t>
+              <a:t>Lookup: skip, retry, reminder-due, and reopen cases</a:t>
             </a:r>
             <a:endParaRPr lang="en-US" sz="1150" dirty="0"/>
           </a:p>
@@ -7976,7 +7882,7 @@
                 <a:ea typeface="Calibri" pitchFamily="34" charset="-122"/>
                 <a:cs typeface="Calibri" pitchFamily="34" charset="-120"/>
               </a:rPr>
-              <a:t>Claim — every eligible item marked pending before send</a:t>
+              <a:t>Claim: every eligible item marked pending before send</a:t>
             </a:r>
             <a:endParaRPr lang="en-US" sz="1150" dirty="0"/>
           </a:p>
@@ -8000,7 +7906,7 @@
                 <a:ea typeface="Calibri" pitchFamily="34" charset="-122"/>
                 <a:cs typeface="Calibri" pitchFamily="34" charset="-120"/>
               </a:rPr>
-              <a:t>Resolve — success → sent, failure → failed, error raised</a:t>
+              <a:t>Resolve: success → sent, failure → failed, error raised</a:t>
             </a:r>
             <a:endParaRPr lang="en-US" sz="1150" dirty="0"/>
           </a:p>
@@ -8024,7 +7930,7 @@
                 <a:ea typeface="Calibri" pitchFamily="34" charset="-122"/>
                 <a:cs typeface="Calibri" pitchFamily="34" charset="-120"/>
               </a:rPr>
-              <a:t>Two-run integration — run 2 sends nothing new right after run 1</a:t>
+              <a:t>Two-run integration: run 2 sends nothing new right after run 1</a:t>
             </a:r>
             <a:endParaRPr lang="en-US" sz="1150" dirty="0"/>
           </a:p>
@@ -8151,7 +8057,7 @@
                 <a:ea typeface="Calibri" pitchFamily="34" charset="-122"/>
                 <a:cs typeface="Calibri" pitchFamily="34" charset="-120"/>
               </a:rPr>
-              <a:t>— 5 mock incidents in → 3 emails out (critical, high, stale). Moderate and resolved incidents produced none.
+              <a:t>: 5 mock incidents in → 3 emails out (critical, high, stale). Moderate and resolved incidents produced none.
 </a:t>
             </a:r>
             <a:pPr algn="l" indent="0" marL="0">
@@ -8186,7 +8092,7 @@
                 <a:ea typeface="Calibri" pitchFamily="34" charset="-122"/>
                 <a:cs typeface="Calibri" pitchFamily="34" charset="-120"/>
               </a:rPr>
-              <a:t>— same static data, run immediately after → 0 new emails. All three keys correctly recognized as already sent.</a:t>
+              <a:t>: same static data, run immediately after → 0 new emails. All three keys correctly recognized as already sent.</a:t>
             </a:r>
             <a:endParaRPr lang="en-US" sz="1300" dirty="0"/>
           </a:p>
@@ -8259,7 +8165,7 @@
                 <a:ea typeface="Calibri" pitchFamily="34" charset="-122"/>
                 <a:cs typeface="Calibri" pitchFamily="34" charset="-120"/>
               </a:rPr>
-              <a:t>Not yet tested — needs live credentials</a:t>
+              <a:t>Not yet tested: needs live credentials</a:t>
             </a:r>
             <a:endParaRPr lang="en-US" sz="1200" dirty="0"/>
           </a:p>
@@ -9094,226 +9000,6 @@
       </p:sp>
       <p:sp>
         <p:nvSpPr>
-          <p:cNvPr id="22" name="Shape 20"/>
-          <p:cNvSpPr/>
-          <p:nvPr/>
-        </p:nvSpPr>
-        <p:spPr>
-          <a:xfrm>
-            <a:off x="548640" y="5074920"/>
-            <a:ext cx="5349240" cy="1188720"/>
-          </a:xfrm>
-          <a:prstGeom prst="roundRect">
-            <a:avLst>
-              <a:gd name="adj" fmla="val 6154"/>
-            </a:avLst>
-          </a:prstGeom>
-          <a:solidFill>
-            <a:schemeClr val="tx2"/>
-          </a:solidFill>
-          <a:ln/>
-          <a:effectLst>
-            <a:outerShdw sx="100000" sy="100000" kx="0" ky="0" algn="bl" rotWithShape="0" blurRad="127000" dist="38100" dir="5400000">
-              <a:srgbClr val="1A1F2B">
-                <a:alpha val="18000"/>
-              </a:srgbClr>
-            </a:outerShdw>
-          </a:effectLst>
-        </p:spPr>
-      </p:sp>
-      <p:sp>
-        <p:nvSpPr>
-          <p:cNvPr id="23" name="Text 21"/>
-          <p:cNvSpPr txBox="1"/>
-          <p:nvPr/>
-        </p:nvSpPr>
-        <p:spPr>
-          <a:xfrm>
-            <a:off x="822960" y="5212080"/>
-            <a:ext cx="4846320" cy="320040"/>
-          </a:xfrm>
-          <a:prstGeom prst="rect">
-            <a:avLst/>
-          </a:prstGeom>
-          <a:noFill/>
-          <a:ln/>
-        </p:spPr>
-        <p:txBody>
-          <a:bodyPr wrap="square" lIns="0" tIns="0" rIns="0" bIns="0" rtlCol="0" anchor="ctr"/>
-          <a:lstStyle/>
-          <a:p>
-            <a:pPr algn="l" indent="0" marL="0">
-              <a:buNone/>
-            </a:pPr>
-            <a:r>
-              <a:rPr lang="en-US" sz="1400" b="1" dirty="0">
-                <a:solidFill>
-                  <a:schemeClr val="accent1"/>
-                </a:solidFill>
-                <a:latin typeface="Cambria" pitchFamily="34" charset="0"/>
-                <a:ea typeface="Cambria" pitchFamily="34" charset="-122"/>
-                <a:cs typeface="Cambria" pitchFamily="34" charset="-120"/>
-              </a:rPr>
-              <a:t>Chethan</a:t>
-            </a:r>
-            <a:endParaRPr lang="en-US" sz="1400" dirty="0"/>
-          </a:p>
-        </p:txBody>
-      </p:sp>
-      <p:sp>
-        <p:nvSpPr>
-          <p:cNvPr id="24" name="Text 22"/>
-          <p:cNvSpPr txBox="1"/>
-          <p:nvPr/>
-        </p:nvSpPr>
-        <p:spPr>
-          <a:xfrm>
-            <a:off x="822960" y="5532120"/>
-            <a:ext cx="4846320" cy="640080"/>
-          </a:xfrm>
-          <a:prstGeom prst="rect">
-            <a:avLst/>
-          </a:prstGeom>
-          <a:noFill/>
-          <a:ln/>
-        </p:spPr>
-        <p:txBody>
-          <a:bodyPr wrap="square" lIns="0" tIns="0" rIns="0" bIns="0" rtlCol="0" anchor="ctr"/>
-          <a:lstStyle/>
-          <a:p>
-            <a:pPr algn="l" indent="0" marL="0">
-              <a:lnSpc>
-                <a:spcPct val="125000"/>
-              </a:lnSpc>
-              <a:buNone/>
-            </a:pPr>
-            <a:r>
-              <a:rPr lang="en-US" sz="1150" dirty="0">
-                <a:solidFill>
-                  <a:srgbClr val="E5E9F0"/>
-                </a:solidFill>
-                <a:latin typeface="Calibri" pitchFamily="34" charset="0"/>
-                <a:ea typeface="Calibri" pitchFamily="34" charset="-122"/>
-                <a:cs typeface="Calibri" pitchFamily="34" charset="-120"/>
-              </a:rPr>
-              <a:t>Design, claim-based dedup implementation, workflow build, testing, ServiceNow connectivity</a:t>
-            </a:r>
-            <a:endParaRPr lang="en-US" sz="1150" dirty="0"/>
-          </a:p>
-        </p:txBody>
-      </p:sp>
-      <p:sp>
-        <p:nvSpPr>
-          <p:cNvPr id="25" name="Shape 23"/>
-          <p:cNvSpPr/>
-          <p:nvPr/>
-        </p:nvSpPr>
-        <p:spPr>
-          <a:xfrm>
-            <a:off x="6080760" y="5074920"/>
-            <a:ext cx="5532120" cy="1188720"/>
-          </a:xfrm>
-          <a:prstGeom prst="roundRect">
-            <a:avLst>
-              <a:gd name="adj" fmla="val 6154"/>
-            </a:avLst>
-          </a:prstGeom>
-          <a:solidFill>
-            <a:schemeClr val="tx2"/>
-          </a:solidFill>
-          <a:ln/>
-          <a:effectLst>
-            <a:outerShdw sx="100000" sy="100000" kx="0" ky="0" algn="bl" rotWithShape="0" blurRad="127000" dist="38100" dir="5400000">
-              <a:srgbClr val="1A1F2B">
-                <a:alpha val="18000"/>
-              </a:srgbClr>
-            </a:outerShdw>
-          </a:effectLst>
-        </p:spPr>
-      </p:sp>
-      <p:sp>
-        <p:nvSpPr>
-          <p:cNvPr id="26" name="Text 24"/>
-          <p:cNvSpPr txBox="1"/>
-          <p:nvPr/>
-        </p:nvSpPr>
-        <p:spPr>
-          <a:xfrm>
-            <a:off x="6355080" y="5212080"/>
-            <a:ext cx="5029200" cy="320040"/>
-          </a:xfrm>
-          <a:prstGeom prst="rect">
-            <a:avLst/>
-          </a:prstGeom>
-          <a:noFill/>
-          <a:ln/>
-        </p:spPr>
-        <p:txBody>
-          <a:bodyPr wrap="square" lIns="0" tIns="0" rIns="0" bIns="0" rtlCol="0" anchor="ctr"/>
-          <a:lstStyle/>
-          <a:p>
-            <a:pPr algn="l" indent="0" marL="0">
-              <a:buNone/>
-            </a:pPr>
-            <a:r>
-              <a:rPr lang="en-US" sz="1400" b="1" dirty="0">
-                <a:solidFill>
-                  <a:schemeClr val="accent3"/>
-                </a:solidFill>
-                <a:latin typeface="Cambria" pitchFamily="34" charset="0"/>
-                <a:ea typeface="Cambria" pitchFamily="34" charset="-122"/>
-                <a:cs typeface="Cambria" pitchFamily="34" charset="-120"/>
-              </a:rPr>
-              <a:t>Sanjna</a:t>
-            </a:r>
-            <a:endParaRPr lang="en-US" sz="1400" dirty="0"/>
-          </a:p>
-        </p:txBody>
-      </p:sp>
-      <p:sp>
-        <p:nvSpPr>
-          <p:cNvPr id="27" name="Text 25"/>
-          <p:cNvSpPr txBox="1"/>
-          <p:nvPr/>
-        </p:nvSpPr>
-        <p:spPr>
-          <a:xfrm>
-            <a:off x="6355080" y="5532120"/>
-            <a:ext cx="5029200" cy="640080"/>
-          </a:xfrm>
-          <a:prstGeom prst="rect">
-            <a:avLst/>
-          </a:prstGeom>
-          <a:noFill/>
-          <a:ln/>
-        </p:spPr>
-        <p:txBody>
-          <a:bodyPr wrap="square" lIns="0" tIns="0" rIns="0" bIns="0" rtlCol="0" anchor="ctr"/>
-          <a:lstStyle/>
-          <a:p>
-            <a:pPr algn="l" indent="0" marL="0">
-              <a:lnSpc>
-                <a:spcPct val="125000"/>
-              </a:lnSpc>
-              <a:buNone/>
-            </a:pPr>
-            <a:r>
-              <a:rPr lang="en-US" sz="1150" dirty="0">
-                <a:solidFill>
-                  <a:srgbClr val="E5E9F0"/>
-                </a:solidFill>
-                <a:latin typeface="Calibri" pitchFamily="34" charset="0"/>
-                <a:ea typeface="Calibri" pitchFamily="34" charset="-122"/>
-                <a:cs typeface="Calibri" pitchFamily="34" charset="-120"/>
-              </a:rPr>
-              <a:t>Gmail SMTP setup + live send test, reminder-firing validation, error-workflow delivery test</a:t>
-            </a:r>
-            <a:endParaRPr lang="en-US" sz="1150" dirty="0"/>
-          </a:p>
-        </p:txBody>
-      </p:sp>
-      <p:sp>
-        <p:nvSpPr>
           <p:cNvPr id="25" name="Slide Number Placeholder 0"/>
           <p:cNvSpPr>
             <a:spLocks noGrp="1"/>
@@ -9357,377 +9043,6 @@
               <a:t>16</a:t>
             </a:fld>
             <a:endParaRPr lang="en-US"/>
-          </a:p>
-        </p:txBody>
-      </p:sp>
-    </p:spTree>
-  </p:cSld>
-  <p:clrMapOvr>
-    <a:masterClrMapping/>
-  </p:clrMapOvr>
-</p:sld>
-</file>
-
-<file path=ppt/slides/slide17.xml><?xml version="1.0" encoding="utf-8"?>
-<p:sld xmlns:a="http://schemas.openxmlformats.org/drawingml/2006/main" xmlns:r="http://schemas.openxmlformats.org/officeDocument/2006/relationships" xmlns:p="http://schemas.openxmlformats.org/presentationml/2006/main">
-  <p:cSld name="Slide 17">
-    <p:spTree>
-      <p:nvGrpSpPr>
-        <p:cNvPr id="1" name=""/>
-        <p:cNvGrpSpPr/>
-        <p:nvPr/>
-      </p:nvGrpSpPr>
-      <p:grpSpPr>
-        <a:xfrm>
-          <a:off x="0" y="0"/>
-          <a:ext cx="0" cy="0"/>
-          <a:chOff x="0" y="0"/>
-          <a:chExt cx="0" cy="0"/>
-        </a:xfrm>
-      </p:grpSpPr>
-      <p:sp>
-        <p:nvSpPr>
-          <p:cNvPr id="2" name="Text 0"/>
-          <p:cNvSpPr/>
-          <p:nvPr>
-            <p:ph idx="100" type="title" hasCustomPrompt="1"/>
-          </p:nvPr>
-        </p:nvSpPr>
-        <p:spPr>
-          <a:xfrm>
-            <a:off x="822960" y="822960"/>
-            <a:ext cx="10515600" cy="1005840"/>
-          </a:xfrm>
-          <a:prstGeom prst="rect">
-            <a:avLst/>
-          </a:prstGeom>
-          <a:noFill/>
-          <a:ln/>
-        </p:spPr>
-        <p:txBody>
-          <a:bodyPr wrap="square" rtlCol="0"/>
-          <a:lstStyle/>
-          <a:p>
-            <a:pPr algn="l" indent="0" marL="0">
-              <a:buNone/>
-            </a:pPr>
-            <a:r>
-              <a:rPr lang="en-US" sz="3600" b="1" dirty="0">
-                <a:solidFill>
-                  <a:schemeClr val="bg1"/>
-                </a:solidFill>
-                <a:latin typeface="Cambria" pitchFamily="34" charset="0"/>
-                <a:ea typeface="Cambria" pitchFamily="34" charset="-122"/>
-                <a:cs typeface="Cambria" pitchFamily="34" charset="-120"/>
-              </a:rPr>
-              <a:t>Status &amp; Next Steps</a:t>
-            </a:r>
-            <a:endParaRPr lang="en-US" sz="3600" dirty="0"/>
-          </a:p>
-        </p:txBody>
-      </p:sp>
-      <p:sp>
-        <p:nvSpPr>
-          <p:cNvPr id="3" name="Text 1"/>
-          <p:cNvSpPr txBox="1"/>
-          <p:nvPr/>
-        </p:nvSpPr>
-        <p:spPr>
-          <a:xfrm>
-            <a:off x="822960" y="2103120"/>
-            <a:ext cx="5120640" cy="365760"/>
-          </a:xfrm>
-          <a:prstGeom prst="rect">
-            <a:avLst/>
-          </a:prstGeom>
-          <a:noFill/>
-          <a:ln/>
-        </p:spPr>
-        <p:txBody>
-          <a:bodyPr wrap="square" lIns="0" tIns="0" rIns="0" bIns="0" rtlCol="0" anchor="ctr"/>
-          <a:lstStyle/>
-          <a:p>
-            <a:pPr algn="l" indent="0" marL="0">
-              <a:buNone/>
-            </a:pPr>
-            <a:r>
-              <a:rPr lang="en-US" sz="1300" b="1" spc="200" kern="0" dirty="0">
-                <a:solidFill>
-                  <a:srgbClr val="7DD3C0"/>
-                </a:solidFill>
-                <a:latin typeface="Calibri" pitchFamily="34" charset="0"/>
-                <a:ea typeface="Calibri" pitchFamily="34" charset="-122"/>
-                <a:cs typeface="Calibri" pitchFamily="34" charset="-120"/>
-              </a:rPr>
-              <a:t>DONE</a:t>
-            </a:r>
-            <a:endParaRPr lang="en-US" sz="1300" dirty="0"/>
-          </a:p>
-        </p:txBody>
-      </p:sp>
-      <p:sp>
-        <p:nvSpPr>
-          <p:cNvPr id="4" name="Text 2"/>
-          <p:cNvSpPr txBox="1"/>
-          <p:nvPr/>
-        </p:nvSpPr>
-        <p:spPr>
-          <a:xfrm>
-            <a:off x="822960" y="2560320"/>
-            <a:ext cx="5120640" cy="2377440"/>
-          </a:xfrm>
-          <a:prstGeom prst="rect">
-            <a:avLst/>
-          </a:prstGeom>
-          <a:noFill/>
-          <a:ln/>
-        </p:spPr>
-        <p:txBody>
-          <a:bodyPr wrap="square" lIns="0" tIns="0" rIns="0" bIns="0" rtlCol="0" anchor="ctr"/>
-          <a:lstStyle/>
-          <a:p>
-            <a:pPr algn="l" marL="342900" indent="-342900">
-              <a:lnSpc>
-                <a:spcPct val="140000"/>
-              </a:lnSpc>
-              <a:spcAft>
-                <a:spcPts val="1000"/>
-              </a:spcAft>
-              <a:buSzPct val="100000"/>
-              <a:buChar char="•"/>
-            </a:pPr>
-            <a:r>
-              <a:rPr lang="en-US" sz="1450" dirty="0">
-                <a:solidFill>
-                  <a:srgbClr val="E5E9F0"/>
-                </a:solidFill>
-                <a:latin typeface="Calibri" pitchFamily="34" charset="0"/>
-                <a:ea typeface="Calibri" pitchFamily="34" charset="-122"/>
-                <a:cs typeface="Calibri" pitchFamily="34" charset="-120"/>
-              </a:rPr>
-              <a:t>Design: reminder policy + claim-based dedup</a:t>
-            </a:r>
-            <a:endParaRPr lang="en-US" sz="1450" dirty="0"/>
-          </a:p>
-          <a:p>
-            <a:pPr algn="l" marL="342900" indent="-342900">
-              <a:lnSpc>
-                <a:spcPct val="140000"/>
-              </a:lnSpc>
-              <a:spcAft>
-                <a:spcPts val="1000"/>
-              </a:spcAft>
-              <a:buSzPct val="100000"/>
-              <a:buChar char="•"/>
-            </a:pPr>
-            <a:r>
-              <a:rPr lang="en-US" sz="1450" dirty="0">
-                <a:solidFill>
-                  <a:srgbClr val="E5E9F0"/>
-                </a:solidFill>
-                <a:latin typeface="Calibri" pitchFamily="34" charset="0"/>
-                <a:ea typeface="Calibri" pitchFamily="34" charset="-122"/>
-                <a:cs typeface="Calibri" pitchFamily="34" charset="-120"/>
-              </a:rPr>
-              <a:t>All code nodes implemented and unit-tested</a:t>
-            </a:r>
-            <a:endParaRPr lang="en-US" sz="1450" dirty="0"/>
-          </a:p>
-          <a:p>
-            <a:pPr algn="l" marL="342900" indent="-342900">
-              <a:lnSpc>
-                <a:spcPct val="140000"/>
-              </a:lnSpc>
-              <a:spcAft>
-                <a:spcPts val="1000"/>
-              </a:spcAft>
-              <a:buSzPct val="100000"/>
-              <a:buChar char="•"/>
-            </a:pPr>
-            <a:r>
-              <a:rPr lang="en-US" sz="1450" dirty="0">
-                <a:solidFill>
-                  <a:srgbClr val="E5E9F0"/>
-                </a:solidFill>
-                <a:latin typeface="Calibri" pitchFamily="34" charset="0"/>
-                <a:ea typeface="Calibri" pitchFamily="34" charset="-122"/>
-                <a:cs typeface="Calibri" pitchFamily="34" charset="-120"/>
-              </a:rPr>
-              <a:t>End-to-end verified on mock ServiceNow + SMTP</a:t>
-            </a:r>
-            <a:endParaRPr lang="en-US" sz="1450" dirty="0"/>
-          </a:p>
-        </p:txBody>
-      </p:sp>
-      <p:sp>
-        <p:nvSpPr>
-          <p:cNvPr id="5" name="Text 3"/>
-          <p:cNvSpPr txBox="1"/>
-          <p:nvPr/>
-        </p:nvSpPr>
-        <p:spPr>
-          <a:xfrm>
-            <a:off x="6400800" y="2103120"/>
-            <a:ext cx="5120640" cy="365760"/>
-          </a:xfrm>
-          <a:prstGeom prst="rect">
-            <a:avLst/>
-          </a:prstGeom>
-          <a:noFill/>
-          <a:ln/>
-        </p:spPr>
-        <p:txBody>
-          <a:bodyPr wrap="square" lIns="0" tIns="0" rIns="0" bIns="0" rtlCol="0" anchor="ctr"/>
-          <a:lstStyle/>
-          <a:p>
-            <a:pPr algn="l" indent="0" marL="0">
-              <a:buNone/>
-            </a:pPr>
-            <a:r>
-              <a:rPr lang="en-US" sz="1300" b="1" spc="200" kern="0" dirty="0">
-                <a:solidFill>
-                  <a:srgbClr val="FFB86B"/>
-                </a:solidFill>
-                <a:latin typeface="Calibri" pitchFamily="34" charset="0"/>
-                <a:ea typeface="Calibri" pitchFamily="34" charset="-122"/>
-                <a:cs typeface="Calibri" pitchFamily="34" charset="-120"/>
-              </a:rPr>
-              <a:t>NEXT</a:t>
-            </a:r>
-            <a:endParaRPr lang="en-US" sz="1300" dirty="0"/>
-          </a:p>
-        </p:txBody>
-      </p:sp>
-      <p:sp>
-        <p:nvSpPr>
-          <p:cNvPr id="6" name="Text 4"/>
-          <p:cNvSpPr txBox="1"/>
-          <p:nvPr/>
-        </p:nvSpPr>
-        <p:spPr>
-          <a:xfrm>
-            <a:off x="6400800" y="2560320"/>
-            <a:ext cx="5120640" cy="2377440"/>
-          </a:xfrm>
-          <a:prstGeom prst="rect">
-            <a:avLst/>
-          </a:prstGeom>
-          <a:noFill/>
-          <a:ln/>
-        </p:spPr>
-        <p:txBody>
-          <a:bodyPr wrap="square" lIns="0" tIns="0" rIns="0" bIns="0" rtlCol="0" anchor="ctr"/>
-          <a:lstStyle/>
-          <a:p>
-            <a:pPr algn="l" marL="342900" indent="-342900">
-              <a:lnSpc>
-                <a:spcPct val="140000"/>
-              </a:lnSpc>
-              <a:spcAft>
-                <a:spcPts val="1000"/>
-              </a:spcAft>
-              <a:buSzPct val="100000"/>
-              <a:buChar char="•"/>
-            </a:pPr>
-            <a:r>
-              <a:rPr lang="en-US" sz="1450" dirty="0">
-                <a:solidFill>
-                  <a:srgbClr val="E5E9F0"/>
-                </a:solidFill>
-                <a:latin typeface="Calibri" pitchFamily="34" charset="0"/>
-                <a:ea typeface="Calibri" pitchFamily="34" charset="-122"/>
-                <a:cs typeface="Calibri" pitchFamily="34" charset="-120"/>
-              </a:rPr>
-              <a:t>Wake dev421307 and seed sample incidents</a:t>
-            </a:r>
-            <a:endParaRPr lang="en-US" sz="1450" dirty="0"/>
-          </a:p>
-          <a:p>
-            <a:pPr algn="l" marL="342900" indent="-342900">
-              <a:lnSpc>
-                <a:spcPct val="140000"/>
-              </a:lnSpc>
-              <a:spcAft>
-                <a:spcPts val="1000"/>
-              </a:spcAft>
-              <a:buSzPct val="100000"/>
-              <a:buChar char="•"/>
-            </a:pPr>
-            <a:r>
-              <a:rPr lang="en-US" sz="1450" dirty="0">
-                <a:solidFill>
-                  <a:srgbClr val="E5E9F0"/>
-                </a:solidFill>
-                <a:latin typeface="Calibri" pitchFamily="34" charset="0"/>
-                <a:ea typeface="Calibri" pitchFamily="34" charset="-122"/>
-                <a:cs typeface="Calibri" pitchFamily="34" charset="-120"/>
-              </a:rPr>
-              <a:t>Wire up Gmail SMTP, run a real send</a:t>
-            </a:r>
-            <a:endParaRPr lang="en-US" sz="1450" dirty="0"/>
-          </a:p>
-          <a:p>
-            <a:pPr algn="l" marL="342900" indent="-342900">
-              <a:lnSpc>
-                <a:spcPct val="140000"/>
-              </a:lnSpc>
-              <a:spcAft>
-                <a:spcPts val="1000"/>
-              </a:spcAft>
-              <a:buSzPct val="100000"/>
-              <a:buChar char="•"/>
-            </a:pPr>
-            <a:r>
-              <a:rPr lang="en-US" sz="1450" dirty="0">
-                <a:solidFill>
-                  <a:srgbClr val="E5E9F0"/>
-                </a:solidFill>
-                <a:latin typeface="Calibri" pitchFamily="34" charset="0"/>
-                <a:ea typeface="Calibri" pitchFamily="34" charset="-122"/>
-                <a:cs typeface="Calibri" pitchFamily="34" charset="-120"/>
-              </a:rPr>
-              <a:t>Validate a reminder firing on a real clock</a:t>
-            </a:r>
-            <a:endParaRPr lang="en-US" sz="1450" dirty="0"/>
-          </a:p>
-        </p:txBody>
-      </p:sp>
-      <p:sp>
-        <p:nvSpPr>
-          <p:cNvPr id="7" name="Text 5"/>
-          <p:cNvSpPr txBox="1"/>
-          <p:nvPr/>
-        </p:nvSpPr>
-        <p:spPr>
-          <a:xfrm>
-            <a:off x="822960" y="6035040"/>
-            <a:ext cx="9144000" cy="365760"/>
-          </a:xfrm>
-          <a:prstGeom prst="rect">
-            <a:avLst/>
-          </a:prstGeom>
-          <a:noFill/>
-          <a:ln/>
-        </p:spPr>
-        <p:txBody>
-          <a:bodyPr wrap="square" lIns="0" tIns="0" rIns="0" bIns="0" rtlCol="0" anchor="ctr"/>
-          <a:lstStyle/>
-          <a:p>
-            <a:pPr algn="l" indent="0" marL="0">
-              <a:buNone/>
-            </a:pPr>
-            <a:r>
-              <a:rPr lang="en-US" sz="1400" dirty="0">
-                <a:solidFill>
-                  <a:schemeClr val="accent1"/>
-                </a:solidFill>
-                <a:latin typeface="Courier New" pitchFamily="34" charset="0"/>
-                <a:ea typeface="Courier New" pitchFamily="34" charset="-122"/>
-                <a:cs typeface="Courier New" pitchFamily="34" charset="-120"/>
-              </a:rPr>
-              <a:t>github.com/Chethan616/n8n-epsilon</a:t>
-            </a:r>
-            <a:endParaRPr lang="en-US" sz="1400" dirty="0"/>
           </a:p>
         </p:txBody>
       </p:sp>
@@ -9874,7 +9189,7 @@
                 <a:ea typeface="Calibri" pitchFamily="34" charset="-122"/>
                 <a:cs typeface="Calibri" pitchFamily="34" charset="-120"/>
               </a:rPr>
-              <a:t>ServiceNow incidents are tracked manually today. There is no automated path from “an incident needs attention” to “the right person was told” — and once an email is sent, nothing ensures it's not sent twice, or that a still-unresolved critical incident gets a second look.</a:t>
+              <a:t>ServiceNow incidents are tracked manually today. There is no automated path from “an incident needs attention” to “the right person was told.” Once an email is sent, nothing ensures it's not sent twice, or that a still-unresolved critical incident gets a second look.</a:t>
             </a:r>
             <a:endParaRPr lang="en-US" sz="1500" dirty="0"/>
           </a:p>
@@ -10226,7 +9541,7 @@
                 <a:ea typeface="Calibri" pitchFamily="34" charset="-122"/>
                 <a:cs typeface="Calibri" pitchFamily="34" charset="-120"/>
               </a:rPr>
-              <a:t>High-priority and stale tickets get no automatic nudge when missed — and no reminder while they stay open.</a:t>
+              <a:t>High-priority and stale tickets get no automatic nudge when missed, and no reminder while they stay open.</a:t>
             </a:r>
             <a:endParaRPr lang="en-US" sz="1300" dirty="0"/>
           </a:p>
@@ -10599,7 +9914,7 @@
                 <a:ea typeface="Calibri" pitchFamily="34" charset="-122"/>
                 <a:cs typeface="Calibri" pitchFamily="34" charset="-120"/>
               </a:rPr>
-              <a:t>Every 5 minutes, n8n polls the ServiceNow Table API, evaluates each incident against alert rules, checks a claim-based dedup store, and emails the team over Gmail SMTP when a rule fires — with reminders for incidents that stay open.</a:t>
+              <a:t>Every 5 minutes, n8n polls the ServiceNow Table API, evaluates each incident against alert rules, checks a claim-based dedup store, and emails the team over Gmail SMTP when a rule fires, with reminders for incidents that stay open.</a:t>
             </a:r>
             <a:endParaRPr lang="en-US" sz="1500" dirty="0"/>
           </a:p>
@@ -10869,7 +10184,7 @@
                 <a:ea typeface="Calibri" pitchFamily="34" charset="-122"/>
                 <a:cs typeface="Calibri" pitchFamily="34" charset="-120"/>
               </a:rPr>
-              <a:t>Evaluate critical / high / stale rules, then claim the alert key before sending — crash-safe, at-least-once.</a:t>
+              <a:t>Evaluate critical / high / stale rules, then claim the alert key before sending. Crash-safe, at-least-once.</a:t>
             </a:r>
             <a:endParaRPr lang="en-US" sz="1350" dirty="0"/>
           </a:p>
@@ -11173,16 +10488,785 @@
         </p:nvSpPr>
         <p:spPr>
           <a:xfrm>
-            <a:off x="548640" y="1874520"/>
-            <a:ext cx="1920240" cy="1371600"/>
+            <a:off x="2240280" y="2263140"/>
+            <a:ext cx="137160" cy="0"/>
+          </a:xfrm>
+          <a:prstGeom prst="line">
+            <a:avLst/>
+          </a:prstGeom>
+          <a:noFill/>
+          <a:ln w="25400">
+            <a:solidFill>
+              <a:schemeClr val="accent2"/>
+            </a:solidFill>
+            <a:prstDash val="solid"/>
+            <a:tailEnd type="none"/>
+          </a:ln>
+        </p:spPr>
+      </p:sp>
+      <p:sp>
+        <p:nvSpPr>
+          <p:cNvPr id="5" name="Shape 3"/>
+          <p:cNvSpPr/>
+          <p:nvPr/>
+        </p:nvSpPr>
+        <p:spPr>
+          <a:xfrm>
+            <a:off x="2377440" y="2263140"/>
+            <a:ext cx="0" cy="662940"/>
+          </a:xfrm>
+          <a:prstGeom prst="line">
+            <a:avLst/>
+          </a:prstGeom>
+          <a:noFill/>
+          <a:ln w="25400">
+            <a:solidFill>
+              <a:schemeClr val="accent2"/>
+            </a:solidFill>
+            <a:prstDash val="solid"/>
+            <a:tailEnd type="none"/>
+          </a:ln>
+        </p:spPr>
+      </p:sp>
+      <p:sp>
+        <p:nvSpPr>
+          <p:cNvPr id="6" name="Shape 4"/>
+          <p:cNvSpPr/>
+          <p:nvPr/>
+        </p:nvSpPr>
+        <p:spPr>
+          <a:xfrm>
+            <a:off x="2377440" y="2926080"/>
+            <a:ext cx="137160" cy="0"/>
+          </a:xfrm>
+          <a:prstGeom prst="line">
+            <a:avLst/>
+          </a:prstGeom>
+          <a:noFill/>
+          <a:ln w="25400">
+            <a:solidFill>
+              <a:schemeClr val="accent2"/>
+            </a:solidFill>
+            <a:prstDash val="solid"/>
+            <a:tailEnd type="triangle"/>
+          </a:ln>
+        </p:spPr>
+      </p:sp>
+      <p:sp>
+        <p:nvSpPr>
+          <p:cNvPr id="7" name="Shape 5"/>
+          <p:cNvSpPr/>
+          <p:nvPr/>
+        </p:nvSpPr>
+        <p:spPr>
+          <a:xfrm>
+            <a:off x="2240280" y="3589020"/>
+            <a:ext cx="137160" cy="0"/>
+          </a:xfrm>
+          <a:prstGeom prst="line">
+            <a:avLst/>
+          </a:prstGeom>
+          <a:noFill/>
+          <a:ln w="25400">
+            <a:solidFill>
+              <a:schemeClr val="accent2"/>
+            </a:solidFill>
+            <a:prstDash val="solid"/>
+            <a:tailEnd type="none"/>
+          </a:ln>
+        </p:spPr>
+      </p:sp>
+      <p:sp>
+        <p:nvSpPr>
+          <p:cNvPr id="8" name="Shape 6"/>
+          <p:cNvSpPr/>
+          <p:nvPr/>
+        </p:nvSpPr>
+        <p:spPr>
+          <a:xfrm>
+            <a:off x="2377440" y="2926080"/>
+            <a:ext cx="0" cy="662940"/>
+          </a:xfrm>
+          <a:prstGeom prst="line">
+            <a:avLst/>
+          </a:prstGeom>
+          <a:noFill/>
+          <a:ln w="25400">
+            <a:solidFill>
+              <a:schemeClr val="accent2"/>
+            </a:solidFill>
+            <a:prstDash val="solid"/>
+            <a:tailEnd type="none"/>
+          </a:ln>
+        </p:spPr>
+      </p:sp>
+      <p:sp>
+        <p:nvSpPr>
+          <p:cNvPr id="9" name="Shape 7"/>
+          <p:cNvSpPr/>
+          <p:nvPr/>
+        </p:nvSpPr>
+        <p:spPr>
+          <a:xfrm>
+            <a:off x="2377440" y="2926080"/>
+            <a:ext cx="137160" cy="0"/>
+          </a:xfrm>
+          <a:prstGeom prst="line">
+            <a:avLst/>
+          </a:prstGeom>
+          <a:noFill/>
+          <a:ln w="25400">
+            <a:solidFill>
+              <a:schemeClr val="accent2"/>
+            </a:solidFill>
+            <a:prstDash val="solid"/>
+            <a:tailEnd type="triangle"/>
+          </a:ln>
+        </p:spPr>
+      </p:sp>
+      <p:sp>
+        <p:nvSpPr>
+          <p:cNvPr id="10" name="Shape 8"/>
+          <p:cNvSpPr/>
+          <p:nvPr/>
+        </p:nvSpPr>
+        <p:spPr>
+          <a:xfrm>
+            <a:off x="4069080" y="2926080"/>
+            <a:ext cx="274320" cy="0"/>
+          </a:xfrm>
+          <a:prstGeom prst="line">
+            <a:avLst/>
+          </a:prstGeom>
+          <a:noFill/>
+          <a:ln w="25400">
+            <a:solidFill>
+              <a:schemeClr val="accent2"/>
+            </a:solidFill>
+            <a:prstDash val="solid"/>
+            <a:tailEnd type="triangle"/>
+          </a:ln>
+        </p:spPr>
+      </p:sp>
+      <p:sp>
+        <p:nvSpPr>
+          <p:cNvPr id="11" name="Shape 9"/>
+          <p:cNvSpPr/>
+          <p:nvPr/>
+        </p:nvSpPr>
+        <p:spPr>
+          <a:xfrm>
+            <a:off x="5897880" y="2926080"/>
+            <a:ext cx="274320" cy="0"/>
+          </a:xfrm>
+          <a:prstGeom prst="line">
+            <a:avLst/>
+          </a:prstGeom>
+          <a:noFill/>
+          <a:ln w="25400">
+            <a:solidFill>
+              <a:schemeClr val="accent2"/>
+            </a:solidFill>
+            <a:prstDash val="solid"/>
+            <a:tailEnd type="triangle"/>
+          </a:ln>
+        </p:spPr>
+      </p:sp>
+      <p:sp>
+        <p:nvSpPr>
+          <p:cNvPr id="12" name="Shape 10"/>
+          <p:cNvSpPr/>
+          <p:nvPr/>
+        </p:nvSpPr>
+        <p:spPr>
+          <a:xfrm>
+            <a:off x="7726680" y="2926080"/>
+            <a:ext cx="274320" cy="0"/>
+          </a:xfrm>
+          <a:prstGeom prst="line">
+            <a:avLst/>
+          </a:prstGeom>
+          <a:noFill/>
+          <a:ln w="25400">
+            <a:solidFill>
+              <a:schemeClr val="accent1"/>
+            </a:solidFill>
+            <a:prstDash val="solid"/>
+            <a:tailEnd type="triangle"/>
+          </a:ln>
+        </p:spPr>
+      </p:sp>
+      <p:sp>
+        <p:nvSpPr>
+          <p:cNvPr id="13" name="Text 11"/>
+          <p:cNvSpPr txBox="1"/>
+          <p:nvPr/>
+        </p:nvSpPr>
+        <p:spPr>
+          <a:xfrm>
+            <a:off x="7223760" y="2523744"/>
+            <a:ext cx="1280160" cy="292608"/>
+          </a:xfrm>
+          <a:prstGeom prst="rect">
+            <a:avLst/>
+          </a:prstGeom>
+          <a:solidFill>
+            <a:srgbClr val="FDFDFB"/>
+          </a:solidFill>
+          <a:ln/>
+        </p:spPr>
+        <p:txBody>
+          <a:bodyPr wrap="square" lIns="0" tIns="0" rIns="0" bIns="0" rtlCol="0" anchor="ctr"/>
+          <a:lstStyle/>
+          <a:p>
+            <a:pPr algn="ctr" indent="0" marL="0">
+              <a:buNone/>
+            </a:pPr>
+            <a:r>
+              <a:rPr lang="en-US" sz="1300" b="1" dirty="0">
+                <a:solidFill>
+                  <a:schemeClr val="accent1"/>
+                </a:solidFill>
+                <a:latin typeface="Calibri" pitchFamily="34" charset="0"/>
+                <a:ea typeface="Calibri" pitchFamily="34" charset="-122"/>
+                <a:cs typeface="Calibri" pitchFamily="34" charset="-120"/>
+              </a:rPr>
+              <a:t>qualifies</a:t>
+            </a:r>
+            <a:endParaRPr lang="en-US" sz="1300" dirty="0"/>
+          </a:p>
+        </p:txBody>
+      </p:sp>
+      <p:sp>
+        <p:nvSpPr>
+          <p:cNvPr id="14" name="Shape 12"/>
+          <p:cNvSpPr/>
+          <p:nvPr/>
+        </p:nvSpPr>
+        <p:spPr>
+          <a:xfrm>
+            <a:off x="6949440" y="3520440"/>
+            <a:ext cx="0" cy="708660"/>
+          </a:xfrm>
+          <a:prstGeom prst="line">
+            <a:avLst/>
+          </a:prstGeom>
+          <a:noFill/>
+          <a:ln w="25400">
+            <a:solidFill>
+              <a:schemeClr val="accent4"/>
+            </a:solidFill>
+            <a:prstDash val="solid"/>
+            <a:tailEnd type="triangle"/>
+          </a:ln>
+        </p:spPr>
+      </p:sp>
+      <p:sp>
+        <p:nvSpPr>
+          <p:cNvPr id="15" name="Text 13"/>
+          <p:cNvSpPr txBox="1"/>
+          <p:nvPr/>
+        </p:nvSpPr>
+        <p:spPr>
+          <a:xfrm>
+            <a:off x="6812280" y="3728466"/>
+            <a:ext cx="1280160" cy="292608"/>
+          </a:xfrm>
+          <a:prstGeom prst="rect">
+            <a:avLst/>
+          </a:prstGeom>
+          <a:solidFill>
+            <a:srgbClr val="FDFDFB"/>
+          </a:solidFill>
+          <a:ln/>
+        </p:spPr>
+        <p:txBody>
+          <a:bodyPr wrap="square" lIns="0" tIns="0" rIns="0" bIns="0" rtlCol="0" anchor="ctr"/>
+          <a:lstStyle/>
+          <a:p>
+            <a:pPr algn="ctr" indent="0" marL="0">
+              <a:buNone/>
+            </a:pPr>
+            <a:r>
+              <a:rPr lang="en-US" sz="1300" b="1" dirty="0">
+                <a:solidFill>
+                  <a:schemeClr val="accent4"/>
+                </a:solidFill>
+                <a:latin typeface="Calibri" pitchFamily="34" charset="0"/>
+                <a:ea typeface="Calibri" pitchFamily="34" charset="-122"/>
+                <a:cs typeface="Calibri" pitchFamily="34" charset="-120"/>
+              </a:rPr>
+              <a:t>no match</a:t>
+            </a:r>
+            <a:endParaRPr lang="en-US" sz="1300" dirty="0"/>
+          </a:p>
+        </p:txBody>
+      </p:sp>
+      <p:sp>
+        <p:nvSpPr>
+          <p:cNvPr id="16" name="Shape 14"/>
+          <p:cNvSpPr/>
+          <p:nvPr/>
+        </p:nvSpPr>
+        <p:spPr>
+          <a:xfrm>
+            <a:off x="9555480" y="2926080"/>
+            <a:ext cx="274320" cy="0"/>
+          </a:xfrm>
+          <a:prstGeom prst="line">
+            <a:avLst/>
+          </a:prstGeom>
+          <a:noFill/>
+          <a:ln w="25400">
+            <a:solidFill>
+              <a:schemeClr val="accent1"/>
+            </a:solidFill>
+            <a:prstDash val="solid"/>
+            <a:tailEnd type="triangle"/>
+          </a:ln>
+        </p:spPr>
+      </p:sp>
+      <p:sp>
+        <p:nvSpPr>
+          <p:cNvPr id="17" name="Text 15"/>
+          <p:cNvSpPr txBox="1"/>
+          <p:nvPr/>
+        </p:nvSpPr>
+        <p:spPr>
+          <a:xfrm>
+            <a:off x="9052560" y="2523744"/>
+            <a:ext cx="1280160" cy="292608"/>
+          </a:xfrm>
+          <a:prstGeom prst="rect">
+            <a:avLst/>
+          </a:prstGeom>
+          <a:solidFill>
+            <a:srgbClr val="FDFDFB"/>
+          </a:solidFill>
+          <a:ln/>
+        </p:spPr>
+        <p:txBody>
+          <a:bodyPr wrap="square" lIns="0" tIns="0" rIns="0" bIns="0" rtlCol="0" anchor="ctr"/>
+          <a:lstStyle/>
+          <a:p>
+            <a:pPr algn="ctr" indent="0" marL="0">
+              <a:buNone/>
+            </a:pPr>
+            <a:r>
+              <a:rPr lang="en-US" sz="1300" b="1" dirty="0">
+                <a:solidFill>
+                  <a:schemeClr val="accent1"/>
+                </a:solidFill>
+                <a:latin typeface="Calibri" pitchFamily="34" charset="0"/>
+                <a:ea typeface="Calibri" pitchFamily="34" charset="-122"/>
+                <a:cs typeface="Calibri" pitchFamily="34" charset="-120"/>
+              </a:rPr>
+              <a:t>no</a:t>
+            </a:r>
+            <a:endParaRPr lang="en-US" sz="1300" dirty="0"/>
+          </a:p>
+        </p:txBody>
+      </p:sp>
+      <p:sp>
+        <p:nvSpPr>
+          <p:cNvPr id="18" name="Shape 16"/>
+          <p:cNvSpPr/>
+          <p:nvPr/>
+        </p:nvSpPr>
+        <p:spPr>
+          <a:xfrm>
+            <a:off x="8778240" y="3520440"/>
+            <a:ext cx="0" cy="228600"/>
+          </a:xfrm>
+          <a:prstGeom prst="line">
+            <a:avLst/>
+          </a:prstGeom>
+          <a:noFill/>
+          <a:ln w="25400">
+            <a:solidFill>
+              <a:schemeClr val="accent4"/>
+            </a:solidFill>
+            <a:prstDash val="solid"/>
+            <a:tailEnd type="none"/>
+          </a:ln>
+        </p:spPr>
+      </p:sp>
+      <p:sp>
+        <p:nvSpPr>
+          <p:cNvPr id="19" name="Shape 17"/>
+          <p:cNvSpPr/>
+          <p:nvPr/>
+        </p:nvSpPr>
+        <p:spPr>
+          <a:xfrm>
+            <a:off x="7955280" y="3749040"/>
+            <a:ext cx="822960" cy="0"/>
+          </a:xfrm>
+          <a:prstGeom prst="line">
+            <a:avLst/>
+          </a:prstGeom>
+          <a:noFill/>
+          <a:ln w="25400">
+            <a:solidFill>
+              <a:schemeClr val="accent4"/>
+            </a:solidFill>
+            <a:prstDash val="solid"/>
+            <a:tailEnd type="none"/>
+          </a:ln>
+        </p:spPr>
+      </p:sp>
+      <p:sp>
+        <p:nvSpPr>
+          <p:cNvPr id="20" name="Shape 18"/>
+          <p:cNvSpPr/>
+          <p:nvPr/>
+        </p:nvSpPr>
+        <p:spPr>
+          <a:xfrm>
+            <a:off x="7955280" y="3749040"/>
+            <a:ext cx="0" cy="480060"/>
+          </a:xfrm>
+          <a:prstGeom prst="line">
+            <a:avLst/>
+          </a:prstGeom>
+          <a:noFill/>
+          <a:ln w="25400">
+            <a:solidFill>
+              <a:schemeClr val="accent4"/>
+            </a:solidFill>
+            <a:prstDash val="solid"/>
+            <a:tailEnd type="triangle"/>
+          </a:ln>
+        </p:spPr>
+      </p:sp>
+      <p:sp>
+        <p:nvSpPr>
+          <p:cNvPr id="21" name="Text 19"/>
+          <p:cNvSpPr txBox="1"/>
+          <p:nvPr/>
+        </p:nvSpPr>
+        <p:spPr>
+          <a:xfrm>
+            <a:off x="8641080" y="3488436"/>
+            <a:ext cx="1280160" cy="292608"/>
+          </a:xfrm>
+          <a:prstGeom prst="rect">
+            <a:avLst/>
+          </a:prstGeom>
+          <a:solidFill>
+            <a:srgbClr val="FDFDFB"/>
+          </a:solidFill>
+          <a:ln/>
+        </p:spPr>
+        <p:txBody>
+          <a:bodyPr wrap="square" lIns="0" tIns="0" rIns="0" bIns="0" rtlCol="0" anchor="ctr"/>
+          <a:lstStyle/>
+          <a:p>
+            <a:pPr algn="ctr" indent="0" marL="0">
+              <a:buNone/>
+            </a:pPr>
+            <a:r>
+              <a:rPr lang="en-US" sz="1300" b="1" dirty="0">
+                <a:solidFill>
+                  <a:schemeClr val="accent4"/>
+                </a:solidFill>
+                <a:latin typeface="Calibri" pitchFamily="34" charset="0"/>
+                <a:ea typeface="Calibri" pitchFamily="34" charset="-122"/>
+                <a:cs typeface="Calibri" pitchFamily="34" charset="-120"/>
+              </a:rPr>
+              <a:t>yes</a:t>
+            </a:r>
+            <a:endParaRPr lang="en-US" sz="1300" dirty="0"/>
+          </a:p>
+        </p:txBody>
+      </p:sp>
+      <p:sp>
+        <p:nvSpPr>
+          <p:cNvPr id="22" name="Shape 20"/>
+          <p:cNvSpPr/>
+          <p:nvPr/>
+        </p:nvSpPr>
+        <p:spPr>
+          <a:xfrm>
+            <a:off x="10607040" y="3314700"/>
+            <a:ext cx="0" cy="891540"/>
+          </a:xfrm>
+          <a:prstGeom prst="line">
+            <a:avLst/>
+          </a:prstGeom>
+          <a:noFill/>
+          <a:ln w="25400">
+            <a:solidFill>
+              <a:schemeClr val="accent1"/>
+            </a:solidFill>
+            <a:prstDash val="solid"/>
+            <a:tailEnd type="none"/>
+          </a:ln>
+        </p:spPr>
+      </p:sp>
+      <p:sp>
+        <p:nvSpPr>
+          <p:cNvPr id="23" name="Shape 21"/>
+          <p:cNvSpPr/>
+          <p:nvPr/>
+        </p:nvSpPr>
+        <p:spPr>
+          <a:xfrm>
+            <a:off x="9692640" y="4206240"/>
+            <a:ext cx="914400" cy="0"/>
+          </a:xfrm>
+          <a:prstGeom prst="line">
+            <a:avLst/>
+          </a:prstGeom>
+          <a:noFill/>
+          <a:ln w="25400">
+            <a:solidFill>
+              <a:schemeClr val="accent1"/>
+            </a:solidFill>
+            <a:prstDash val="solid"/>
+            <a:tailEnd type="none"/>
+          </a:ln>
+        </p:spPr>
+      </p:sp>
+      <p:sp>
+        <p:nvSpPr>
+          <p:cNvPr id="24" name="Shape 22"/>
+          <p:cNvSpPr/>
+          <p:nvPr/>
+        </p:nvSpPr>
+        <p:spPr>
+          <a:xfrm>
+            <a:off x="9692640" y="4206240"/>
+            <a:ext cx="0" cy="274320"/>
+          </a:xfrm>
+          <a:prstGeom prst="line">
+            <a:avLst/>
+          </a:prstGeom>
+          <a:noFill/>
+          <a:ln w="25400">
+            <a:solidFill>
+              <a:schemeClr val="accent1"/>
+            </a:solidFill>
+            <a:prstDash val="solid"/>
+            <a:tailEnd type="triangle"/>
+          </a:ln>
+        </p:spPr>
+      </p:sp>
+      <p:sp>
+        <p:nvSpPr>
+          <p:cNvPr id="25" name="Shape 23"/>
+          <p:cNvSpPr/>
+          <p:nvPr/>
+        </p:nvSpPr>
+        <p:spPr>
+          <a:xfrm>
+            <a:off x="8778240" y="3520440"/>
+            <a:ext cx="0" cy="868680"/>
+          </a:xfrm>
+          <a:prstGeom prst="line">
+            <a:avLst/>
+          </a:prstGeom>
+          <a:noFill/>
+          <a:ln w="25400">
+            <a:solidFill>
+              <a:schemeClr val="accent4"/>
+            </a:solidFill>
+            <a:prstDash val="dash"/>
+            <a:tailEnd type="none"/>
+          </a:ln>
+        </p:spPr>
+      </p:sp>
+      <p:sp>
+        <p:nvSpPr>
+          <p:cNvPr id="26" name="Shape 24"/>
+          <p:cNvSpPr/>
+          <p:nvPr/>
+        </p:nvSpPr>
+        <p:spPr>
+          <a:xfrm>
+            <a:off x="8778240" y="4389120"/>
+            <a:ext cx="365760" cy="0"/>
+          </a:xfrm>
+          <a:prstGeom prst="line">
+            <a:avLst/>
+          </a:prstGeom>
+          <a:noFill/>
+          <a:ln w="25400">
+            <a:solidFill>
+              <a:schemeClr val="accent4"/>
+            </a:solidFill>
+            <a:prstDash val="dash"/>
+            <a:tailEnd type="none"/>
+          </a:ln>
+        </p:spPr>
+      </p:sp>
+      <p:sp>
+        <p:nvSpPr>
+          <p:cNvPr id="27" name="Shape 25"/>
+          <p:cNvSpPr/>
+          <p:nvPr/>
+        </p:nvSpPr>
+        <p:spPr>
+          <a:xfrm>
+            <a:off x="9144000" y="4389120"/>
+            <a:ext cx="0" cy="91440"/>
+          </a:xfrm>
+          <a:prstGeom prst="line">
+            <a:avLst/>
+          </a:prstGeom>
+          <a:noFill/>
+          <a:ln w="25400">
+            <a:solidFill>
+              <a:schemeClr val="accent4"/>
+            </a:solidFill>
+            <a:prstDash val="dash"/>
+            <a:tailEnd type="triangle"/>
+          </a:ln>
+        </p:spPr>
+      </p:sp>
+      <p:sp>
+        <p:nvSpPr>
+          <p:cNvPr id="28" name="Text 26"/>
+          <p:cNvSpPr txBox="1"/>
+          <p:nvPr/>
+        </p:nvSpPr>
+        <p:spPr>
+          <a:xfrm>
+            <a:off x="8732520" y="3808476"/>
+            <a:ext cx="1280160" cy="292608"/>
+          </a:xfrm>
+          <a:prstGeom prst="rect">
+            <a:avLst/>
+          </a:prstGeom>
+          <a:solidFill>
+            <a:srgbClr val="FDFDFB"/>
+          </a:solidFill>
+          <a:ln/>
+        </p:spPr>
+        <p:txBody>
+          <a:bodyPr wrap="square" lIns="0" tIns="0" rIns="0" bIns="0" rtlCol="0" anchor="ctr"/>
+          <a:lstStyle/>
+          <a:p>
+            <a:pPr algn="ctr" indent="0" marL="0">
+              <a:buNone/>
+            </a:pPr>
+            <a:r>
+              <a:rPr lang="en-US" sz="1300" b="1" dirty="0">
+                <a:solidFill>
+                  <a:schemeClr val="accent4"/>
+                </a:solidFill>
+                <a:latin typeface="Calibri" pitchFamily="34" charset="0"/>
+                <a:ea typeface="Calibri" pitchFamily="34" charset="-122"/>
+                <a:cs typeface="Calibri" pitchFamily="34" charset="-120"/>
+              </a:rPr>
+              <a:t>lookup</a:t>
+            </a:r>
+            <a:endParaRPr lang="en-US" sz="1300" dirty="0"/>
+          </a:p>
+        </p:txBody>
+      </p:sp>
+      <p:sp>
+        <p:nvSpPr>
+          <p:cNvPr id="29" name="Shape 27"/>
+          <p:cNvSpPr/>
+          <p:nvPr/>
+        </p:nvSpPr>
+        <p:spPr>
+          <a:xfrm>
+            <a:off x="685800" y="1920240"/>
+            <a:ext cx="1554480" cy="685800"/>
           </a:xfrm>
           <a:prstGeom prst="roundRect">
             <a:avLst>
-              <a:gd name="adj" fmla="val 5333"/>
+              <a:gd name="adj" fmla="val 9333"/>
             </a:avLst>
           </a:prstGeom>
           <a:solidFill>
-            <a:schemeClr val="bg1"/>
+            <a:schemeClr val="tx2"/>
+          </a:solidFill>
+          <a:ln/>
+        </p:spPr>
+      </p:sp>
+      <p:sp>
+        <p:nvSpPr>
+          <p:cNvPr id="30" name="Text 28"/>
+          <p:cNvSpPr txBox="1"/>
+          <p:nvPr/>
+        </p:nvSpPr>
+        <p:spPr>
+          <a:xfrm>
+            <a:off x="758952" y="1920240"/>
+            <a:ext cx="1408176" cy="685800"/>
+          </a:xfrm>
+          <a:prstGeom prst="rect">
+            <a:avLst/>
+          </a:prstGeom>
+          <a:noFill/>
+          <a:ln/>
+        </p:spPr>
+        <p:txBody>
+          <a:bodyPr wrap="square" lIns="0" tIns="0" rIns="0" bIns="0" rtlCol="0" anchor="ctr"/>
+          <a:lstStyle/>
+          <a:p>
+            <a:pPr algn="ctr" indent="0" marL="0">
+              <a:lnSpc>
+                <a:spcPct val="115000"/>
+              </a:lnSpc>
+              <a:buNone/>
+            </a:pPr>
+            <a:r>
+              <a:rPr lang="en-US" sz="1300" b="1" dirty="0">
+                <a:solidFill>
+                  <a:srgbClr val="FFFFFF"/>
+                </a:solidFill>
+                <a:latin typeface="Calibri" pitchFamily="34" charset="0"/>
+                <a:ea typeface="Calibri" pitchFamily="34" charset="-122"/>
+                <a:cs typeface="Calibri" pitchFamily="34" charset="-120"/>
+              </a:rPr>
+              <a:t>ServiceNow</a:t>
+            </a:r>
+            <a:endParaRPr lang="en-US" sz="1300" dirty="0"/>
+          </a:p>
+          <a:p>
+            <a:pPr algn="ctr" indent="0" marL="0">
+              <a:lnSpc>
+                <a:spcPct val="115000"/>
+              </a:lnSpc>
+              <a:buNone/>
+            </a:pPr>
+            <a:r>
+              <a:rPr lang="en-US" sz="1300" b="1" dirty="0">
+                <a:solidFill>
+                  <a:srgbClr val="FFFFFF"/>
+                </a:solidFill>
+                <a:latin typeface="Calibri" pitchFamily="34" charset="0"/>
+                <a:ea typeface="Calibri" pitchFamily="34" charset="-122"/>
+                <a:cs typeface="Calibri" pitchFamily="34" charset="-120"/>
+              </a:rPr>
+              <a:t>Incident Table</a:t>
+            </a:r>
+            <a:endParaRPr lang="en-US" sz="1300" dirty="0"/>
+          </a:p>
+        </p:txBody>
+      </p:sp>
+      <p:sp>
+        <p:nvSpPr>
+          <p:cNvPr id="31" name="Shape 29"/>
+          <p:cNvSpPr/>
+          <p:nvPr/>
+        </p:nvSpPr>
+        <p:spPr>
+          <a:xfrm>
+            <a:off x="685800" y="3246120"/>
+            <a:ext cx="1554480" cy="685800"/>
+          </a:xfrm>
+          <a:prstGeom prst="roundRect">
+            <a:avLst>
+              <a:gd name="adj" fmla="val 9333"/>
+            </a:avLst>
+          </a:prstGeom>
+          <a:solidFill>
+            <a:srgbClr val="FFFFFF"/>
           </a:solidFill>
           <a:ln w="12700">
             <a:solidFill>
@@ -11190,64 +11274,18 @@
             </a:solidFill>
             <a:prstDash val="solid"/>
           </a:ln>
-          <a:effectLst>
-            <a:outerShdw sx="100000" sy="100000" kx="0" ky="0" algn="bl" rotWithShape="0" blurRad="127000" dist="38100" dir="5400000">
-              <a:srgbClr val="1A1F2B">
-                <a:alpha val="18000"/>
-              </a:srgbClr>
-            </a:outerShdw>
-          </a:effectLst>
-        </p:spPr>
-      </p:sp>
-      <p:sp>
-        <p:nvSpPr>
-          <p:cNvPr id="5" name="Text 3"/>
+        </p:spPr>
+      </p:sp>
+      <p:sp>
+        <p:nvSpPr>
+          <p:cNvPr id="32" name="Text 30"/>
           <p:cNvSpPr txBox="1"/>
           <p:nvPr/>
         </p:nvSpPr>
         <p:spPr>
           <a:xfrm>
-            <a:off x="640080" y="2039112"/>
-            <a:ext cx="1737360" cy="457200"/>
-          </a:xfrm>
-          <a:prstGeom prst="rect">
-            <a:avLst/>
-          </a:prstGeom>
-          <a:noFill/>
-          <a:ln/>
-        </p:spPr>
-        <p:txBody>
-          <a:bodyPr wrap="square" lIns="0" tIns="0" rIns="0" bIns="0" rtlCol="0" anchor="ctr"/>
-          <a:lstStyle/>
-          <a:p>
-            <a:pPr algn="ctr" indent="0" marL="0">
-              <a:buNone/>
-            </a:pPr>
-            <a:r>
-              <a:rPr lang="en-US" sz="1500" b="1" dirty="0">
-                <a:solidFill>
-                  <a:schemeClr val="tx1"/>
-                </a:solidFill>
-                <a:latin typeface="Cambria" pitchFamily="34" charset="0"/>
-                <a:ea typeface="Cambria" pitchFamily="34" charset="-122"/>
-                <a:cs typeface="Cambria" pitchFamily="34" charset="-120"/>
-              </a:rPr>
-              <a:t>ServiceNow</a:t>
-            </a:r>
-            <a:endParaRPr lang="en-US" sz="1500" dirty="0"/>
-          </a:p>
-        </p:txBody>
-      </p:sp>
-      <p:sp>
-        <p:nvSpPr>
-          <p:cNvPr id="6" name="Text 4"/>
-          <p:cNvSpPr txBox="1"/>
-          <p:nvPr/>
-        </p:nvSpPr>
-        <p:spPr>
-          <a:xfrm>
-            <a:off x="640080" y="2496312"/>
-            <a:ext cx="1737360" cy="685800"/>
+            <a:off x="758952" y="3246120"/>
+            <a:ext cx="1408176" cy="685800"/>
           </a:xfrm>
           <a:prstGeom prst="rect">
             <a:avLst/>
@@ -11261,103 +11299,63 @@
           <a:p>
             <a:pPr algn="ctr" indent="0" marL="0">
               <a:lnSpc>
-                <a:spcPct val="120000"/>
+                <a:spcPct val="115000"/>
               </a:lnSpc>
               <a:buNone/>
             </a:pPr>
             <a:r>
-              <a:rPr lang="en-US" sz="1100" dirty="0">
-                <a:solidFill>
-                  <a:schemeClr val="accent6"/>
+              <a:rPr lang="en-US" sz="1300" b="1" dirty="0">
+                <a:solidFill>
+                  <a:schemeClr val="tx1"/>
                 </a:solidFill>
                 <a:latin typeface="Calibri" pitchFamily="34" charset="0"/>
                 <a:ea typeface="Calibri" pitchFamily="34" charset="-122"/>
                 <a:cs typeface="Calibri" pitchFamily="34" charset="-120"/>
               </a:rPr>
-              <a:t>Incident records</a:t>
-            </a:r>
-            <a:endParaRPr lang="en-US" sz="1100" dirty="0"/>
+              <a:t>Schedule Trigger</a:t>
+            </a:r>
+            <a:endParaRPr lang="en-US" sz="1300" dirty="0"/>
           </a:p>
           <a:p>
             <a:pPr algn="ctr" indent="0" marL="0">
               <a:lnSpc>
-                <a:spcPct val="120000"/>
+                <a:spcPct val="115000"/>
               </a:lnSpc>
               <a:buNone/>
             </a:pPr>
             <a:r>
-              <a:rPr lang="en-US" sz="1100" dirty="0">
-                <a:solidFill>
-                  <a:schemeClr val="accent6"/>
+              <a:rPr lang="en-US" sz="1300" b="1" dirty="0">
+                <a:solidFill>
+                  <a:schemeClr val="tx1"/>
                 </a:solidFill>
                 <a:latin typeface="Calibri" pitchFamily="34" charset="0"/>
                 <a:ea typeface="Calibri" pitchFamily="34" charset="-122"/>
                 <a:cs typeface="Calibri" pitchFamily="34" charset="-120"/>
               </a:rPr>
-              <a:t>priority, state</a:t>
-            </a:r>
-            <a:endParaRPr lang="en-US" sz="1100" dirty="0"/>
-          </a:p>
-        </p:txBody>
-      </p:sp>
-      <p:sp>
-        <p:nvSpPr>
-          <p:cNvPr id="7" name="Shape 5"/>
+              <a:t>every 5 min</a:t>
+            </a:r>
+            <a:endParaRPr lang="en-US" sz="1300" dirty="0"/>
+          </a:p>
+        </p:txBody>
+      </p:sp>
+      <p:sp>
+        <p:nvSpPr>
+          <p:cNvPr id="33" name="Shape 31"/>
           <p:cNvSpPr/>
           <p:nvPr/>
         </p:nvSpPr>
         <p:spPr>
           <a:xfrm>
-            <a:off x="548640" y="1874520"/>
-            <a:ext cx="1920240" cy="54864"/>
-          </a:xfrm>
-          <a:prstGeom prst="roundRect">
-            <a:avLst/>
-          </a:prstGeom>
-          <a:solidFill>
-            <a:schemeClr val="tx1"/>
-          </a:solidFill>
-          <a:ln/>
-        </p:spPr>
-      </p:sp>
-      <p:sp>
-        <p:nvSpPr>
-          <p:cNvPr id="8" name="Shape 6"/>
-          <p:cNvSpPr/>
-          <p:nvPr/>
-        </p:nvSpPr>
-        <p:spPr>
-          <a:xfrm>
-            <a:off x="2496312" y="2423160"/>
-            <a:ext cx="265176" cy="274320"/>
-          </a:xfrm>
-          <a:prstGeom prst="rightArrow">
-            <a:avLst/>
-          </a:prstGeom>
-          <a:solidFill>
-            <a:schemeClr val="accent4"/>
-          </a:solidFill>
-          <a:ln/>
-        </p:spPr>
-      </p:sp>
-      <p:sp>
-        <p:nvSpPr>
-          <p:cNvPr id="9" name="Shape 7"/>
-          <p:cNvSpPr/>
-          <p:nvPr/>
-        </p:nvSpPr>
-        <p:spPr>
-          <a:xfrm>
-            <a:off x="2788920" y="1874520"/>
-            <a:ext cx="1920240" cy="1371600"/>
+            <a:off x="2514600" y="2537460"/>
+            <a:ext cx="1554480" cy="777240"/>
           </a:xfrm>
           <a:prstGeom prst="roundRect">
             <a:avLst>
-              <a:gd name="adj" fmla="val 5333"/>
+              <a:gd name="adj" fmla="val 8235"/>
             </a:avLst>
           </a:prstGeom>
           <a:solidFill>
-            <a:schemeClr val="bg1"/>
+            <a:srgbClr val="FFFFFF"/>
           </a:solidFill>
           <a:ln w="12700">
             <a:solidFill>
@@ -11365,64 +11363,18 @@
             </a:solidFill>
             <a:prstDash val="solid"/>
           </a:ln>
-          <a:effectLst>
-            <a:outerShdw sx="100000" sy="100000" kx="0" ky="0" algn="bl" rotWithShape="0" blurRad="127000" dist="38100" dir="5400000">
-              <a:srgbClr val="1A1F2B">
-                <a:alpha val="18000"/>
-              </a:srgbClr>
-            </a:outerShdw>
-          </a:effectLst>
-        </p:spPr>
-      </p:sp>
-      <p:sp>
-        <p:nvSpPr>
-          <p:cNvPr id="10" name="Text 8"/>
+        </p:spPr>
+      </p:sp>
+      <p:sp>
+        <p:nvSpPr>
+          <p:cNvPr id="34" name="Text 32"/>
           <p:cNvSpPr txBox="1"/>
           <p:nvPr/>
         </p:nvSpPr>
         <p:spPr>
           <a:xfrm>
-            <a:off x="2880360" y="2039112"/>
-            <a:ext cx="1737360" cy="457200"/>
-          </a:xfrm>
-          <a:prstGeom prst="rect">
-            <a:avLst/>
-          </a:prstGeom>
-          <a:noFill/>
-          <a:ln/>
-        </p:spPr>
-        <p:txBody>
-          <a:bodyPr wrap="square" lIns="0" tIns="0" rIns="0" bIns="0" rtlCol="0" anchor="ctr"/>
-          <a:lstStyle/>
-          <a:p>
-            <a:pPr algn="ctr" indent="0" marL="0">
-              <a:buNone/>
-            </a:pPr>
-            <a:r>
-              <a:rPr lang="en-US" sz="1500" b="1" dirty="0">
-                <a:solidFill>
-                  <a:schemeClr val="tx1"/>
-                </a:solidFill>
-                <a:latin typeface="Cambria" pitchFamily="34" charset="0"/>
-                <a:ea typeface="Cambria" pitchFamily="34" charset="-122"/>
-                <a:cs typeface="Cambria" pitchFamily="34" charset="-120"/>
-              </a:rPr>
-              <a:t>n8n</a:t>
-            </a:r>
-            <a:endParaRPr lang="en-US" sz="1500" dirty="0"/>
-          </a:p>
-        </p:txBody>
-      </p:sp>
-      <p:sp>
-        <p:nvSpPr>
-          <p:cNvPr id="11" name="Text 9"/>
-          <p:cNvSpPr txBox="1"/>
-          <p:nvPr/>
-        </p:nvSpPr>
-        <p:spPr>
-          <a:xfrm>
-            <a:off x="2880360" y="2496312"/>
-            <a:ext cx="1737360" cy="685800"/>
+            <a:off x="2587752" y="2537460"/>
+            <a:ext cx="1408176" cy="777240"/>
           </a:xfrm>
           <a:prstGeom prst="rect">
             <a:avLst/>
@@ -11436,103 +11388,63 @@
           <a:p>
             <a:pPr algn="ctr" indent="0" marL="0">
               <a:lnSpc>
-                <a:spcPct val="120000"/>
+                <a:spcPct val="115000"/>
               </a:lnSpc>
               <a:buNone/>
             </a:pPr>
             <a:r>
-              <a:rPr lang="en-US" sz="1100" dirty="0">
-                <a:solidFill>
-                  <a:schemeClr val="accent6"/>
+              <a:rPr lang="en-US" sz="1300" b="1" dirty="0">
+                <a:solidFill>
+                  <a:schemeClr val="tx1"/>
                 </a:solidFill>
                 <a:latin typeface="Calibri" pitchFamily="34" charset="0"/>
                 <a:ea typeface="Calibri" pitchFamily="34" charset="-122"/>
                 <a:cs typeface="Calibri" pitchFamily="34" charset="-120"/>
               </a:rPr>
-              <a:t>Schedule + orchestration</a:t>
-            </a:r>
-            <a:endParaRPr lang="en-US" sz="1100" dirty="0"/>
+              <a:t>HTTP Request</a:t>
+            </a:r>
+            <a:endParaRPr lang="en-US" sz="1300" dirty="0"/>
           </a:p>
           <a:p>
             <a:pPr algn="ctr" indent="0" marL="0">
               <a:lnSpc>
-                <a:spcPct val="120000"/>
+                <a:spcPct val="115000"/>
               </a:lnSpc>
               <a:buNone/>
             </a:pPr>
             <a:r>
-              <a:rPr lang="en-US" sz="1100" dirty="0">
-                <a:solidFill>
-                  <a:schemeClr val="accent6"/>
+              <a:rPr lang="en-US" sz="1300" b="1" dirty="0">
+                <a:solidFill>
+                  <a:schemeClr val="tx1"/>
                 </a:solidFill>
                 <a:latin typeface="Calibri" pitchFamily="34" charset="0"/>
                 <a:ea typeface="Calibri" pitchFamily="34" charset="-122"/>
                 <a:cs typeface="Calibri" pitchFamily="34" charset="-120"/>
               </a:rPr>
-              <a:t>every 5 minutes</a:t>
-            </a:r>
-            <a:endParaRPr lang="en-US" sz="1100" dirty="0"/>
-          </a:p>
-        </p:txBody>
-      </p:sp>
-      <p:sp>
-        <p:nvSpPr>
-          <p:cNvPr id="12" name="Shape 10"/>
+              <a:t>n8n</a:t>
+            </a:r>
+            <a:endParaRPr lang="en-US" sz="1300" dirty="0"/>
+          </a:p>
+        </p:txBody>
+      </p:sp>
+      <p:sp>
+        <p:nvSpPr>
+          <p:cNvPr id="35" name="Shape 33"/>
           <p:cNvSpPr/>
           <p:nvPr/>
         </p:nvSpPr>
         <p:spPr>
           <a:xfrm>
-            <a:off x="2788920" y="1874520"/>
-            <a:ext cx="1920240" cy="54864"/>
-          </a:xfrm>
-          <a:prstGeom prst="roundRect">
-            <a:avLst/>
-          </a:prstGeom>
-          <a:solidFill>
-            <a:schemeClr val="accent2"/>
-          </a:solidFill>
-          <a:ln/>
-        </p:spPr>
-      </p:sp>
-      <p:sp>
-        <p:nvSpPr>
-          <p:cNvPr id="13" name="Shape 11"/>
-          <p:cNvSpPr/>
-          <p:nvPr/>
-        </p:nvSpPr>
-        <p:spPr>
-          <a:xfrm>
-            <a:off x="4736592" y="2423160"/>
-            <a:ext cx="265176" cy="274320"/>
-          </a:xfrm>
-          <a:prstGeom prst="rightArrow">
-            <a:avLst/>
-          </a:prstGeom>
-          <a:solidFill>
-            <a:schemeClr val="accent4"/>
-          </a:solidFill>
-          <a:ln/>
-        </p:spPr>
-      </p:sp>
-      <p:sp>
-        <p:nvSpPr>
-          <p:cNvPr id="14" name="Shape 12"/>
-          <p:cNvSpPr/>
-          <p:nvPr/>
-        </p:nvSpPr>
-        <p:spPr>
-          <a:xfrm>
-            <a:off x="5029200" y="1874520"/>
-            <a:ext cx="1920240" cy="1371600"/>
+            <a:off x="4343400" y="2537460"/>
+            <a:ext cx="1554480" cy="777240"/>
           </a:xfrm>
           <a:prstGeom prst="roundRect">
             <a:avLst>
-              <a:gd name="adj" fmla="val 5333"/>
+              <a:gd name="adj" fmla="val 8235"/>
             </a:avLst>
           </a:prstGeom>
           <a:solidFill>
-            <a:schemeClr val="bg1"/>
+            <a:srgbClr val="FFFFFF"/>
           </a:solidFill>
           <a:ln w="12700">
             <a:solidFill>
@@ -11540,64 +11452,18 @@
             </a:solidFill>
             <a:prstDash val="solid"/>
           </a:ln>
-          <a:effectLst>
-            <a:outerShdw sx="100000" sy="100000" kx="0" ky="0" algn="bl" rotWithShape="0" blurRad="127000" dist="38100" dir="5400000">
-              <a:srgbClr val="1A1F2B">
-                <a:alpha val="18000"/>
-              </a:srgbClr>
-            </a:outerShdw>
-          </a:effectLst>
-        </p:spPr>
-      </p:sp>
-      <p:sp>
-        <p:nvSpPr>
-          <p:cNvPr id="15" name="Text 13"/>
+        </p:spPr>
+      </p:sp>
+      <p:sp>
+        <p:nvSpPr>
+          <p:cNvPr id="36" name="Text 34"/>
           <p:cNvSpPr txBox="1"/>
           <p:nvPr/>
         </p:nvSpPr>
         <p:spPr>
           <a:xfrm>
-            <a:off x="5120640" y="2039112"/>
-            <a:ext cx="1737360" cy="457200"/>
-          </a:xfrm>
-          <a:prstGeom prst="rect">
-            <a:avLst/>
-          </a:prstGeom>
-          <a:noFill/>
-          <a:ln/>
-        </p:spPr>
-        <p:txBody>
-          <a:bodyPr wrap="square" lIns="0" tIns="0" rIns="0" bIns="0" rtlCol="0" anchor="ctr"/>
-          <a:lstStyle/>
-          <a:p>
-            <a:pPr algn="ctr" indent="0" marL="0">
-              <a:buNone/>
-            </a:pPr>
-            <a:r>
-              <a:rPr lang="en-US" sz="1500" b="1" dirty="0">
-                <a:solidFill>
-                  <a:schemeClr val="tx1"/>
-                </a:solidFill>
-                <a:latin typeface="Cambria" pitchFamily="34" charset="0"/>
-                <a:ea typeface="Cambria" pitchFamily="34" charset="-122"/>
-                <a:cs typeface="Cambria" pitchFamily="34" charset="-120"/>
-              </a:rPr>
-              <a:t>REST API</a:t>
-            </a:r>
-            <a:endParaRPr lang="en-US" sz="1500" dirty="0"/>
-          </a:p>
-        </p:txBody>
-      </p:sp>
-      <p:sp>
-        <p:nvSpPr>
-          <p:cNvPr id="16" name="Text 14"/>
-          <p:cNvSpPr txBox="1"/>
-          <p:nvPr/>
-        </p:nvSpPr>
-        <p:spPr>
-          <a:xfrm>
-            <a:off x="5120640" y="2496312"/>
-            <a:ext cx="1737360" cy="685800"/>
+            <a:off x="4416552" y="2537460"/>
+            <a:ext cx="1408176" cy="777240"/>
           </a:xfrm>
           <a:prstGeom prst="rect">
             <a:avLst/>
@@ -11611,103 +11477,227 @@
           <a:p>
             <a:pPr algn="ctr" indent="0" marL="0">
               <a:lnSpc>
-                <a:spcPct val="120000"/>
+                <a:spcPct val="115000"/>
               </a:lnSpc>
               <a:buNone/>
             </a:pPr>
             <a:r>
-              <a:rPr lang="en-US" sz="1100" dirty="0">
-                <a:solidFill>
-                  <a:schemeClr val="accent6"/>
+              <a:rPr lang="en-US" sz="1300" b="1" dirty="0">
+                <a:solidFill>
+                  <a:schemeClr val="tx1"/>
                 </a:solidFill>
                 <a:latin typeface="Calibri" pitchFamily="34" charset="0"/>
                 <a:ea typeface="Calibri" pitchFamily="34" charset="-122"/>
                 <a:cs typeface="Calibri" pitchFamily="34" charset="-120"/>
               </a:rPr>
-              <a:t>Authenticated GET</a:t>
-            </a:r>
-            <a:endParaRPr lang="en-US" sz="1100" dirty="0"/>
+              <a:t>Split Out</a:t>
+            </a:r>
+            <a:endParaRPr lang="en-US" sz="1300" dirty="0"/>
           </a:p>
           <a:p>
             <a:pPr algn="ctr" indent="0" marL="0">
               <a:lnSpc>
-                <a:spcPct val="120000"/>
+                <a:spcPct val="115000"/>
               </a:lnSpc>
               <a:buNone/>
             </a:pPr>
             <a:r>
-              <a:rPr lang="en-US" sz="1100" dirty="0">
-                <a:solidFill>
-                  <a:schemeClr val="accent6"/>
+              <a:rPr lang="en-US" sz="1300" b="1" dirty="0">
+                <a:solidFill>
+                  <a:schemeClr val="tx1"/>
                 </a:solidFill>
                 <a:latin typeface="Calibri" pitchFamily="34" charset="0"/>
                 <a:ea typeface="Calibri" pitchFamily="34" charset="-122"/>
                 <a:cs typeface="Calibri" pitchFamily="34" charset="-120"/>
               </a:rPr>
-              <a:t>Table API</a:t>
-            </a:r>
-            <a:endParaRPr lang="en-US" sz="1100" dirty="0"/>
-          </a:p>
-        </p:txBody>
-      </p:sp>
-      <p:sp>
-        <p:nvSpPr>
-          <p:cNvPr id="17" name="Shape 15"/>
+              <a:t>1 item / incident</a:t>
+            </a:r>
+            <a:endParaRPr lang="en-US" sz="1300" dirty="0"/>
+          </a:p>
+        </p:txBody>
+      </p:sp>
+      <p:sp>
+        <p:nvSpPr>
+          <p:cNvPr id="37" name="Shape 35"/>
           <p:cNvSpPr/>
           <p:nvPr/>
         </p:nvSpPr>
         <p:spPr>
           <a:xfrm>
-            <a:off x="5029200" y="1874520"/>
-            <a:ext cx="1920240" cy="54864"/>
-          </a:xfrm>
-          <a:prstGeom prst="roundRect">
+            <a:off x="6172200" y="2331720"/>
+            <a:ext cx="1554480" cy="1188720"/>
+          </a:xfrm>
+          <a:prstGeom prst="diamond">
             <a:avLst/>
           </a:prstGeom>
           <a:solidFill>
-            <a:schemeClr val="accent2"/>
+            <a:schemeClr val="accent1"/>
           </a:solidFill>
           <a:ln/>
         </p:spPr>
       </p:sp>
       <p:sp>
         <p:nvSpPr>
-          <p:cNvPr id="18" name="Shape 16"/>
+          <p:cNvPr id="38" name="Text 36"/>
+          <p:cNvSpPr txBox="1"/>
+          <p:nvPr/>
+        </p:nvSpPr>
+        <p:spPr>
+          <a:xfrm>
+            <a:off x="6172200" y="2331720"/>
+            <a:ext cx="1554480" cy="1188720"/>
+          </a:xfrm>
+          <a:prstGeom prst="rect">
+            <a:avLst/>
+          </a:prstGeom>
+          <a:noFill/>
+          <a:ln/>
+        </p:spPr>
+        <p:txBody>
+          <a:bodyPr wrap="square" lIns="0" tIns="0" rIns="0" bIns="0" rtlCol="0" anchor="ctr"/>
+          <a:lstStyle/>
+          <a:p>
+            <a:pPr algn="ctr" indent="0" marL="0">
+              <a:lnSpc>
+                <a:spcPct val="110000"/>
+              </a:lnSpc>
+              <a:buNone/>
+            </a:pPr>
+            <a:r>
+              <a:rPr lang="en-US" sz="1300" b="1" dirty="0">
+                <a:solidFill>
+                  <a:srgbClr val="FFFFFF"/>
+                </a:solidFill>
+                <a:latin typeface="Calibri" pitchFamily="34" charset="0"/>
+                <a:ea typeface="Calibri" pitchFamily="34" charset="-122"/>
+                <a:cs typeface="Calibri" pitchFamily="34" charset="-120"/>
+              </a:rPr>
+              <a:t>Evaluate</a:t>
+            </a:r>
+            <a:endParaRPr lang="en-US" sz="1300" dirty="0"/>
+          </a:p>
+          <a:p>
+            <a:pPr algn="ctr" indent="0" marL="0">
+              <a:lnSpc>
+                <a:spcPct val="110000"/>
+              </a:lnSpc>
+              <a:buNone/>
+            </a:pPr>
+            <a:r>
+              <a:rPr lang="en-US" sz="1300" b="1" dirty="0">
+                <a:solidFill>
+                  <a:srgbClr val="FFFFFF"/>
+                </a:solidFill>
+                <a:latin typeface="Calibri" pitchFamily="34" charset="0"/>
+                <a:ea typeface="Calibri" pitchFamily="34" charset="-122"/>
+                <a:cs typeface="Calibri" pitchFamily="34" charset="-120"/>
+              </a:rPr>
+              <a:t>rules</a:t>
+            </a:r>
+            <a:endParaRPr lang="en-US" sz="1300" dirty="0"/>
+          </a:p>
+        </p:txBody>
+      </p:sp>
+      <p:sp>
+        <p:nvSpPr>
+          <p:cNvPr id="39" name="Shape 37"/>
           <p:cNvSpPr/>
           <p:nvPr/>
         </p:nvSpPr>
         <p:spPr>
           <a:xfrm>
-            <a:off x="6976872" y="2423160"/>
-            <a:ext cx="265176" cy="274320"/>
-          </a:xfrm>
-          <a:prstGeom prst="rightArrow">
+            <a:off x="8001000" y="2331720"/>
+            <a:ext cx="1554480" cy="1188720"/>
+          </a:xfrm>
+          <a:prstGeom prst="diamond">
             <a:avLst/>
           </a:prstGeom>
           <a:solidFill>
-            <a:schemeClr val="accent4"/>
+            <a:schemeClr val="accent1"/>
           </a:solidFill>
           <a:ln/>
         </p:spPr>
       </p:sp>
       <p:sp>
         <p:nvSpPr>
-          <p:cNvPr id="19" name="Shape 17"/>
+          <p:cNvPr id="40" name="Text 38"/>
+          <p:cNvSpPr txBox="1"/>
+          <p:nvPr/>
+        </p:nvSpPr>
+        <p:spPr>
+          <a:xfrm>
+            <a:off x="8001000" y="2331720"/>
+            <a:ext cx="1554480" cy="1188720"/>
+          </a:xfrm>
+          <a:prstGeom prst="rect">
+            <a:avLst/>
+          </a:prstGeom>
+          <a:noFill/>
+          <a:ln/>
+        </p:spPr>
+        <p:txBody>
+          <a:bodyPr wrap="square" lIns="0" tIns="0" rIns="0" bIns="0" rtlCol="0" anchor="ctr"/>
+          <a:lstStyle/>
+          <a:p>
+            <a:pPr algn="ctr" indent="0" marL="0">
+              <a:lnSpc>
+                <a:spcPct val="110000"/>
+              </a:lnSpc>
+              <a:buNone/>
+            </a:pPr>
+            <a:r>
+              <a:rPr lang="en-US" sz="1300" b="1" dirty="0">
+                <a:solidFill>
+                  <a:srgbClr val="FFFFFF"/>
+                </a:solidFill>
+                <a:latin typeface="Calibri" pitchFamily="34" charset="0"/>
+                <a:ea typeface="Calibri" pitchFamily="34" charset="-122"/>
+                <a:cs typeface="Calibri" pitchFamily="34" charset="-120"/>
+              </a:rPr>
+              <a:t>Already</a:t>
+            </a:r>
+            <a:endParaRPr lang="en-US" sz="1300" dirty="0"/>
+          </a:p>
+          <a:p>
+            <a:pPr algn="ctr" indent="0" marL="0">
+              <a:lnSpc>
+                <a:spcPct val="110000"/>
+              </a:lnSpc>
+              <a:buNone/>
+            </a:pPr>
+            <a:r>
+              <a:rPr lang="en-US" sz="1300" b="1" dirty="0">
+                <a:solidFill>
+                  <a:srgbClr val="FFFFFF"/>
+                </a:solidFill>
+                <a:latin typeface="Calibri" pitchFamily="34" charset="0"/>
+                <a:ea typeface="Calibri" pitchFamily="34" charset="-122"/>
+                <a:cs typeface="Calibri" pitchFamily="34" charset="-120"/>
+              </a:rPr>
+              <a:t>notified?</a:t>
+            </a:r>
+            <a:endParaRPr lang="en-US" sz="1300" dirty="0"/>
+          </a:p>
+        </p:txBody>
+      </p:sp>
+      <p:sp>
+        <p:nvSpPr>
+          <p:cNvPr id="41" name="Shape 39"/>
           <p:cNvSpPr/>
           <p:nvPr/>
         </p:nvSpPr>
         <p:spPr>
           <a:xfrm>
-            <a:off x="7269480" y="1874520"/>
-            <a:ext cx="1920240" cy="1371600"/>
+            <a:off x="6766560" y="4229100"/>
+            <a:ext cx="1463040" cy="685800"/>
           </a:xfrm>
           <a:prstGeom prst="roundRect">
             <a:avLst>
-              <a:gd name="adj" fmla="val 5333"/>
+              <a:gd name="adj" fmla="val 9333"/>
             </a:avLst>
           </a:prstGeom>
           <a:solidFill>
-            <a:schemeClr val="bg1"/>
+            <a:srgbClr val="FFFFFF"/>
           </a:solidFill>
           <a:ln w="12700">
             <a:solidFill>
@@ -11715,81 +11705,18 @@
             </a:solidFill>
             <a:prstDash val="solid"/>
           </a:ln>
-          <a:effectLst>
-            <a:outerShdw sx="100000" sy="100000" kx="0" ky="0" algn="bl" rotWithShape="0" blurRad="127000" dist="38100" dir="5400000">
-              <a:srgbClr val="1A1F2B">
-                <a:alpha val="18000"/>
-              </a:srgbClr>
-            </a:outerShdw>
-          </a:effectLst>
-        </p:spPr>
-      </p:sp>
-      <p:sp>
-        <p:nvSpPr>
-          <p:cNvPr id="20" name="Text 18"/>
+        </p:spPr>
+      </p:sp>
+      <p:sp>
+        <p:nvSpPr>
+          <p:cNvPr id="42" name="Text 40"/>
           <p:cNvSpPr txBox="1"/>
           <p:nvPr/>
         </p:nvSpPr>
         <p:spPr>
           <a:xfrm>
-            <a:off x="7360920" y="2039112"/>
-            <a:ext cx="1737360" cy="457200"/>
-          </a:xfrm>
-          <a:prstGeom prst="rect">
-            <a:avLst/>
-          </a:prstGeom>
-          <a:noFill/>
-          <a:ln/>
-        </p:spPr>
-        <p:txBody>
-          <a:bodyPr wrap="square" lIns="0" tIns="0" rIns="0" bIns="0" rtlCol="0" anchor="ctr"/>
-          <a:lstStyle/>
-          <a:p>
-            <a:pPr algn="ctr" indent="0" marL="0">
-              <a:buNone/>
-            </a:pPr>
-            <a:r>
-              <a:rPr lang="en-US" sz="1500" b="1" dirty="0">
-                <a:solidFill>
-                  <a:schemeClr val="tx1"/>
-                </a:solidFill>
-                <a:latin typeface="Cambria" pitchFamily="34" charset="0"/>
-                <a:ea typeface="Cambria" pitchFamily="34" charset="-122"/>
-                <a:cs typeface="Cambria" pitchFamily="34" charset="-120"/>
-              </a:rPr>
-              <a:t>Evaluate +</a:t>
-            </a:r>
-            <a:endParaRPr lang="en-US" sz="1500" dirty="0"/>
-          </a:p>
-          <a:p>
-            <a:pPr algn="ctr" indent="0" marL="0">
-              <a:buNone/>
-            </a:pPr>
-            <a:r>
-              <a:rPr lang="en-US" sz="1500" b="1" dirty="0">
-                <a:solidFill>
-                  <a:schemeClr val="tx1"/>
-                </a:solidFill>
-                <a:latin typeface="Cambria" pitchFamily="34" charset="0"/>
-                <a:ea typeface="Cambria" pitchFamily="34" charset="-122"/>
-                <a:cs typeface="Cambria" pitchFamily="34" charset="-120"/>
-              </a:rPr>
-              <a:t>Claim</a:t>
-            </a:r>
-            <a:endParaRPr lang="en-US" sz="1500" dirty="0"/>
-          </a:p>
-        </p:txBody>
-      </p:sp>
-      <p:sp>
-        <p:nvSpPr>
-          <p:cNvPr id="21" name="Text 19"/>
-          <p:cNvSpPr txBox="1"/>
-          <p:nvPr/>
-        </p:nvSpPr>
-        <p:spPr>
-          <a:xfrm>
-            <a:off x="7360920" y="2496312"/>
-            <a:ext cx="1737360" cy="685800"/>
+            <a:off x="6839712" y="4229100"/>
+            <a:ext cx="1316736" cy="685800"/>
           </a:xfrm>
           <a:prstGeom prst="rect">
             <a:avLst/>
@@ -11803,12 +11730,12 @@
           <a:p>
             <a:pPr algn="ctr" indent="0" marL="0">
               <a:lnSpc>
-                <a:spcPct val="120000"/>
+                <a:spcPct val="115000"/>
               </a:lnSpc>
               <a:buNone/>
             </a:pPr>
             <a:r>
-              <a:rPr lang="en-US" sz="1100" dirty="0">
+              <a:rPr lang="en-US" sz="1300" b="1" dirty="0">
                 <a:solidFill>
                   <a:schemeClr val="accent6"/>
                 </a:solidFill>
@@ -11816,90 +11743,30 @@
                 <a:ea typeface="Calibri" pitchFamily="34" charset="-122"/>
                 <a:cs typeface="Calibri" pitchFamily="34" charset="-120"/>
               </a:rPr>
-              <a:t>Critical / high / stale</a:t>
-            </a:r>
-            <a:endParaRPr lang="en-US" sz="1100" dirty="0"/>
-          </a:p>
-          <a:p>
-            <a:pPr algn="ctr" indent="0" marL="0">
-              <a:lnSpc>
-                <a:spcPct val="120000"/>
-              </a:lnSpc>
-              <a:buNone/>
-            </a:pPr>
-            <a:r>
-              <a:rPr lang="en-US" sz="1100" dirty="0">
-                <a:solidFill>
-                  <a:schemeClr val="accent6"/>
-                </a:solidFill>
-                <a:latin typeface="Calibri" pitchFamily="34" charset="0"/>
-                <a:ea typeface="Calibri" pitchFamily="34" charset="-122"/>
-                <a:cs typeface="Calibri" pitchFamily="34" charset="-120"/>
-              </a:rPr>
-              <a:t>+ dedup store</a:t>
-            </a:r>
-            <a:endParaRPr lang="en-US" sz="1100" dirty="0"/>
-          </a:p>
-        </p:txBody>
-      </p:sp>
-      <p:sp>
-        <p:nvSpPr>
-          <p:cNvPr id="22" name="Shape 20"/>
+              <a:t>Skip</a:t>
+            </a:r>
+            <a:endParaRPr lang="en-US" sz="1300" dirty="0"/>
+          </a:p>
+        </p:txBody>
+      </p:sp>
+      <p:sp>
+        <p:nvSpPr>
+          <p:cNvPr id="43" name="Shape 41"/>
           <p:cNvSpPr/>
           <p:nvPr/>
         </p:nvSpPr>
         <p:spPr>
           <a:xfrm>
-            <a:off x="7269480" y="1874520"/>
-            <a:ext cx="1920240" cy="54864"/>
-          </a:xfrm>
-          <a:prstGeom prst="roundRect">
-            <a:avLst/>
-          </a:prstGeom>
-          <a:solidFill>
-            <a:schemeClr val="accent1"/>
-          </a:solidFill>
-          <a:ln/>
-        </p:spPr>
-      </p:sp>
-      <p:sp>
-        <p:nvSpPr>
-          <p:cNvPr id="23" name="Shape 21"/>
-          <p:cNvSpPr/>
-          <p:nvPr/>
-        </p:nvSpPr>
-        <p:spPr>
-          <a:xfrm>
-            <a:off x="9217152" y="2423160"/>
-            <a:ext cx="265176" cy="274320"/>
-          </a:xfrm>
-          <a:prstGeom prst="rightArrow">
-            <a:avLst/>
-          </a:prstGeom>
-          <a:solidFill>
-            <a:schemeClr val="accent4"/>
-          </a:solidFill>
-          <a:ln/>
-        </p:spPr>
-      </p:sp>
-      <p:sp>
-        <p:nvSpPr>
-          <p:cNvPr id="24" name="Shape 22"/>
-          <p:cNvSpPr/>
-          <p:nvPr/>
-        </p:nvSpPr>
-        <p:spPr>
-          <a:xfrm>
-            <a:off x="9509760" y="1874520"/>
-            <a:ext cx="1920240" cy="1371600"/>
+            <a:off x="9829800" y="2537460"/>
+            <a:ext cx="1554480" cy="777240"/>
           </a:xfrm>
           <a:prstGeom prst="roundRect">
             <a:avLst>
-              <a:gd name="adj" fmla="val 5333"/>
+              <a:gd name="adj" fmla="val 8235"/>
             </a:avLst>
           </a:prstGeom>
           <a:solidFill>
-            <a:schemeClr val="bg1"/>
+            <a:srgbClr val="FFFFFF"/>
           </a:solidFill>
           <a:ln w="12700">
             <a:solidFill>
@@ -11907,64 +11774,18 @@
             </a:solidFill>
             <a:prstDash val="solid"/>
           </a:ln>
-          <a:effectLst>
-            <a:outerShdw sx="100000" sy="100000" kx="0" ky="0" algn="bl" rotWithShape="0" blurRad="127000" dist="38100" dir="5400000">
-              <a:srgbClr val="1A1F2B">
-                <a:alpha val="18000"/>
-              </a:srgbClr>
-            </a:outerShdw>
-          </a:effectLst>
-        </p:spPr>
-      </p:sp>
-      <p:sp>
-        <p:nvSpPr>
-          <p:cNvPr id="25" name="Text 23"/>
+        </p:spPr>
+      </p:sp>
+      <p:sp>
+        <p:nvSpPr>
+          <p:cNvPr id="44" name="Text 42"/>
           <p:cNvSpPr txBox="1"/>
           <p:nvPr/>
         </p:nvSpPr>
         <p:spPr>
           <a:xfrm>
-            <a:off x="9601200" y="2039112"/>
-            <a:ext cx="1737360" cy="457200"/>
-          </a:xfrm>
-          <a:prstGeom prst="rect">
-            <a:avLst/>
-          </a:prstGeom>
-          <a:noFill/>
-          <a:ln/>
-        </p:spPr>
-        <p:txBody>
-          <a:bodyPr wrap="square" lIns="0" tIns="0" rIns="0" bIns="0" rtlCol="0" anchor="ctr"/>
-          <a:lstStyle/>
-          <a:p>
-            <a:pPr algn="ctr" indent="0" marL="0">
-              <a:buNone/>
-            </a:pPr>
-            <a:r>
-              <a:rPr lang="en-US" sz="1500" b="1" dirty="0">
-                <a:solidFill>
-                  <a:schemeClr val="tx1"/>
-                </a:solidFill>
-                <a:latin typeface="Cambria" pitchFamily="34" charset="0"/>
-                <a:ea typeface="Cambria" pitchFamily="34" charset="-122"/>
-                <a:cs typeface="Cambria" pitchFamily="34" charset="-120"/>
-              </a:rPr>
-              <a:t>Gmail SMTP</a:t>
-            </a:r>
-            <a:endParaRPr lang="en-US" sz="1500" dirty="0"/>
-          </a:p>
-        </p:txBody>
-      </p:sp>
-      <p:sp>
-        <p:nvSpPr>
-          <p:cNvPr id="26" name="Text 24"/>
-          <p:cNvSpPr txBox="1"/>
-          <p:nvPr/>
-        </p:nvSpPr>
-        <p:spPr>
-          <a:xfrm>
-            <a:off x="9601200" y="2496312"/>
-            <a:ext cx="1737360" cy="685800"/>
+            <a:off x="9902952" y="2537460"/>
+            <a:ext cx="1408176" cy="777240"/>
           </a:xfrm>
           <a:prstGeom prst="rect">
             <a:avLst/>
@@ -11978,143 +11799,77 @@
           <a:p>
             <a:pPr algn="ctr" indent="0" marL="0">
               <a:lnSpc>
-                <a:spcPct val="120000"/>
+                <a:spcPct val="115000"/>
               </a:lnSpc>
               <a:buNone/>
             </a:pPr>
             <a:r>
-              <a:rPr lang="en-US" sz="1100" dirty="0">
-                <a:solidFill>
-                  <a:schemeClr val="accent6"/>
+              <a:rPr lang="en-US" sz="1300" b="1" dirty="0">
+                <a:solidFill>
+                  <a:schemeClr val="tx1"/>
                 </a:solidFill>
                 <a:latin typeface="Calibri" pitchFamily="34" charset="0"/>
                 <a:ea typeface="Calibri" pitchFamily="34" charset="-122"/>
                 <a:cs typeface="Calibri" pitchFamily="34" charset="-120"/>
               </a:rPr>
-              <a:t>Structured alert</a:t>
-            </a:r>
-            <a:endParaRPr lang="en-US" sz="1100" dirty="0"/>
+              <a:t>Send Email</a:t>
+            </a:r>
+            <a:endParaRPr lang="en-US" sz="1300" dirty="0"/>
           </a:p>
           <a:p>
             <a:pPr algn="ctr" indent="0" marL="0">
               <a:lnSpc>
-                <a:spcPct val="120000"/>
+                <a:spcPct val="115000"/>
               </a:lnSpc>
               <a:buNone/>
             </a:pPr>
             <a:r>
-              <a:rPr lang="en-US" sz="1100" dirty="0">
-                <a:solidFill>
-                  <a:schemeClr val="accent6"/>
+              <a:rPr lang="en-US" sz="1300" b="1" dirty="0">
+                <a:solidFill>
+                  <a:schemeClr val="tx1"/>
                 </a:solidFill>
                 <a:latin typeface="Calibri" pitchFamily="34" charset="0"/>
                 <a:ea typeface="Calibri" pitchFamily="34" charset="-122"/>
                 <a:cs typeface="Calibri" pitchFamily="34" charset="-120"/>
               </a:rPr>
-              <a:t>email</a:t>
-            </a:r>
-            <a:endParaRPr lang="en-US" sz="1100" dirty="0"/>
-          </a:p>
-        </p:txBody>
-      </p:sp>
-      <p:sp>
-        <p:nvSpPr>
-          <p:cNvPr id="27" name="Shape 25"/>
+              <a:t>Gmail SMTP</a:t>
+            </a:r>
+            <a:endParaRPr lang="en-US" sz="1300" dirty="0"/>
+          </a:p>
+        </p:txBody>
+      </p:sp>
+      <p:sp>
+        <p:nvSpPr>
+          <p:cNvPr id="45" name="Shape 43"/>
           <p:cNvSpPr/>
           <p:nvPr/>
         </p:nvSpPr>
         <p:spPr>
           <a:xfrm>
-            <a:off x="9509760" y="1874520"/>
-            <a:ext cx="1920240" cy="54864"/>
-          </a:xfrm>
-          <a:prstGeom prst="roundRect">
-            <a:avLst/>
-          </a:prstGeom>
-          <a:solidFill>
-            <a:schemeClr val="accent1"/>
-          </a:solidFill>
-          <a:ln/>
-        </p:spPr>
-      </p:sp>
-      <p:sp>
-        <p:nvSpPr>
-          <p:cNvPr id="28" name="Shape 26"/>
-          <p:cNvSpPr/>
-          <p:nvPr/>
-        </p:nvSpPr>
-        <p:spPr>
-          <a:xfrm>
-            <a:off x="3931920" y="3931920"/>
-            <a:ext cx="4297680" cy="1371600"/>
+            <a:off x="8503920" y="4480560"/>
+            <a:ext cx="2377440" cy="914400"/>
           </a:xfrm>
           <a:prstGeom prst="roundRect">
             <a:avLst>
-              <a:gd name="adj" fmla="val 5333"/>
+              <a:gd name="adj" fmla="val 7000"/>
             </a:avLst>
           </a:prstGeom>
           <a:solidFill>
             <a:schemeClr val="tx2"/>
           </a:solidFill>
           <a:ln/>
-          <a:effectLst>
-            <a:outerShdw sx="100000" sy="100000" kx="0" ky="0" algn="bl" rotWithShape="0" blurRad="127000" dist="38100" dir="5400000">
-              <a:srgbClr val="1A1F2B">
-                <a:alpha val="18000"/>
-              </a:srgbClr>
-            </a:outerShdw>
-          </a:effectLst>
-        </p:spPr>
-      </p:sp>
-      <p:sp>
-        <p:nvSpPr>
-          <p:cNvPr id="29" name="Text 27"/>
+        </p:spPr>
+      </p:sp>
+      <p:sp>
+        <p:nvSpPr>
+          <p:cNvPr id="46" name="Text 44"/>
           <p:cNvSpPr txBox="1"/>
           <p:nvPr/>
         </p:nvSpPr>
         <p:spPr>
           <a:xfrm>
-            <a:off x="4206240" y="4114800"/>
-            <a:ext cx="3749040" cy="365760"/>
-          </a:xfrm>
-          <a:prstGeom prst="rect">
-            <a:avLst/>
-          </a:prstGeom>
-          <a:noFill/>
-          <a:ln/>
-        </p:spPr>
-        <p:txBody>
-          <a:bodyPr wrap="square" lIns="0" tIns="0" rIns="0" bIns="0" rtlCol="0" anchor="ctr"/>
-          <a:lstStyle/>
-          <a:p>
-            <a:pPr algn="ctr" indent="0" marL="0">
-              <a:buNone/>
-            </a:pPr>
-            <a:r>
-              <a:rPr lang="en-US" sz="1500" b="1" dirty="0">
-                <a:solidFill>
-                  <a:srgbClr val="FFFFFF"/>
-                </a:solidFill>
-                <a:latin typeface="Cambria" pitchFamily="34" charset="0"/>
-                <a:ea typeface="Cambria" pitchFamily="34" charset="-122"/>
-                <a:cs typeface="Cambria" pitchFamily="34" charset="-120"/>
-              </a:rPr>
-              <a:t>Alert State Store</a:t>
-            </a:r>
-            <a:endParaRPr lang="en-US" sz="1500" dirty="0"/>
-          </a:p>
-        </p:txBody>
-      </p:sp>
-      <p:sp>
-        <p:nvSpPr>
-          <p:cNvPr id="30" name="Text 28"/>
-          <p:cNvSpPr txBox="1"/>
-          <p:nvPr/>
-        </p:nvSpPr>
-        <p:spPr>
-          <a:xfrm>
-            <a:off x="4206240" y="4526280"/>
-            <a:ext cx="3749040" cy="640080"/>
+            <a:off x="8577072" y="4480560"/>
+            <a:ext cx="2231136" cy="914400"/>
           </a:xfrm>
           <a:prstGeom prst="rect">
             <a:avLst/>
@@ -12128,83 +11883,79 @@
           <a:p>
             <a:pPr algn="ctr" indent="0" marL="0">
               <a:lnSpc>
-                <a:spcPct val="130000"/>
+                <a:spcPct val="115000"/>
               </a:lnSpc>
               <a:buNone/>
             </a:pPr>
             <a:r>
-              <a:rPr lang="en-US" sz="1100" dirty="0">
-                <a:solidFill>
-                  <a:srgbClr val="AEB8C9"/>
+              <a:rPr lang="en-US" sz="1300" b="1" dirty="0">
+                <a:solidFill>
+                  <a:srgbClr val="FFFFFF"/>
                 </a:solidFill>
                 <a:latin typeface="Calibri" pitchFamily="34" charset="0"/>
                 <a:ea typeface="Calibri" pitchFamily="34" charset="-122"/>
                 <a:cs typeface="Calibri" pitchFamily="34" charset="-120"/>
               </a:rPr>
-              <a:t>key = incident + alert type  →  status, claimed_at, last_notified_at, incident_state</a:t>
-            </a:r>
-            <a:endParaRPr lang="en-US" sz="1100" dirty="0"/>
-          </a:p>
-        </p:txBody>
-      </p:sp>
-      <p:sp>
-        <p:nvSpPr>
-          <p:cNvPr id="31" name="Shape 29"/>
-          <p:cNvSpPr/>
-          <p:nvPr/>
-        </p:nvSpPr>
-        <p:spPr>
-          <a:xfrm>
-            <a:off x="6080760" y="3246120"/>
-            <a:ext cx="0" cy="685800"/>
-          </a:xfrm>
-          <a:prstGeom prst="line">
-            <a:avLst/>
-          </a:prstGeom>
-          <a:noFill/>
-          <a:ln w="25400">
-            <a:solidFill>
-              <a:schemeClr val="accent1"/>
-            </a:solidFill>
-            <a:prstDash val="dash"/>
-            <a:tailEnd type="triangle"/>
-          </a:ln>
-        </p:spPr>
-      </p:sp>
-      <p:sp>
-        <p:nvSpPr>
-          <p:cNvPr id="32" name="Text 30"/>
-          <p:cNvSpPr txBox="1"/>
-          <p:nvPr/>
-        </p:nvSpPr>
-        <p:spPr>
-          <a:xfrm>
-            <a:off x="548640" y="6035040"/>
-            <a:ext cx="11064240" cy="365760"/>
-          </a:xfrm>
-          <a:prstGeom prst="rect">
-            <a:avLst/>
-          </a:prstGeom>
-          <a:noFill/>
-          <a:ln/>
-        </p:spPr>
-        <p:txBody>
-          <a:bodyPr wrap="square" lIns="0" tIns="0" rIns="0" bIns="0" rtlCol="0" anchor="ctr"/>
-          <a:lstStyle/>
-          <a:p>
-            <a:pPr algn="l" indent="0" marL="0">
-              <a:buNone/>
-            </a:pPr>
-            <a:r>
-              <a:rPr lang="en-US" sz="1200" i="1" dirty="0">
-                <a:solidFill>
-                  <a:schemeClr val="accent4"/>
+              <a:t>Alert State Store</a:t>
+            </a:r>
+            <a:endParaRPr lang="en-US" sz="1300" dirty="0"/>
+          </a:p>
+          <a:p>
+            <a:pPr algn="ctr" indent="0" marL="0">
+              <a:lnSpc>
+                <a:spcPct val="115000"/>
+              </a:lnSpc>
+              <a:buNone/>
+            </a:pPr>
+            <a:r>
+              <a:rPr lang="en-US" sz="1300" b="1" dirty="0">
+                <a:solidFill>
+                  <a:srgbClr val="FFFFFF"/>
                 </a:solidFill>
                 <a:latin typeface="Calibri" pitchFamily="34" charset="0"/>
                 <a:ea typeface="Calibri" pitchFamily="34" charset="-122"/>
                 <a:cs typeface="Calibri" pitchFamily="34" charset="-120"/>
               </a:rPr>
-              <a:t>Execution logs and error handling (retries, visible failures) apply at every step.</a:t>
+              <a:t>incident + alert type</a:t>
+            </a:r>
+            <a:endParaRPr lang="en-US" sz="1300" dirty="0"/>
+          </a:p>
+        </p:txBody>
+      </p:sp>
+      <p:sp>
+        <p:nvSpPr>
+          <p:cNvPr id="47" name="Text 45"/>
+          <p:cNvSpPr txBox="1"/>
+          <p:nvPr/>
+        </p:nvSpPr>
+        <p:spPr>
+          <a:xfrm>
+            <a:off x="548640" y="5989320"/>
+            <a:ext cx="11064240" cy="365760"/>
+          </a:xfrm>
+          <a:prstGeom prst="rect">
+            <a:avLst/>
+          </a:prstGeom>
+          <a:noFill/>
+          <a:ln/>
+        </p:spPr>
+        <p:txBody>
+          <a:bodyPr wrap="square" lIns="0" tIns="0" rIns="0" bIns="0" rtlCol="0" anchor="ctr"/>
+          <a:lstStyle/>
+          <a:p>
+            <a:pPr algn="l" indent="0" marL="0">
+              <a:buNone/>
+            </a:pPr>
+            <a:r>
+              <a:rPr lang="en-US" sz="1200" i="1" dirty="0">
+                <a:solidFill>
+                  <a:schemeClr val="accent4"/>
+                </a:solidFill>
+                <a:latin typeface="Calibri" pitchFamily="34" charset="0"/>
+                <a:ea typeface="Calibri" pitchFamily="34" charset="-122"/>
+                <a:cs typeface="Calibri" pitchFamily="34" charset="-120"/>
+              </a:rPr>
+              <a:t>Dashed line: the dedup check's lookup against the Alert State Store before deciding to send.</a:t>
             </a:r>
             <a:endParaRPr lang="en-US" sz="1200" dirty="0"/>
           </a:p>
@@ -12496,7 +12247,7 @@
                 <a:ea typeface="Calibri" pitchFamily="34" charset="-122"/>
                 <a:cs typeface="Calibri" pitchFamily="34" charset="-120"/>
               </a:rPr>
-              <a:t>Incident source — Table API, personal developer instance</a:t>
+              <a:t>Incident source: Table API, personal developer instance</a:t>
             </a:r>
             <a:endParaRPr lang="en-US" sz="1200" dirty="0"/>
           </a:p>
@@ -12633,7 +12384,7 @@
                 <a:ea typeface="Calibri" pitchFamily="34" charset="-122"/>
                 <a:cs typeface="Calibri" pitchFamily="34" charset="-120"/>
               </a:rPr>
-              <a:t>Self-hosted orchestration — Schedule, HTTP, Code, IF nodes</a:t>
+              <a:t>Self-hosted orchestration: Schedule, HTTP, Code, IF nodes</a:t>
             </a:r>
             <a:endParaRPr lang="en-US" sz="1200" dirty="0"/>
           </a:p>
@@ -13044,7 +12795,7 @@
                 <a:ea typeface="Calibri" pitchFamily="34" charset="-122"/>
                 <a:cs typeface="Calibri" pitchFamily="34" charset="-120"/>
               </a:rPr>
-              <a:t>Persistent dedup store — survives restarts on active workflows</a:t>
+              <a:t>Persistent dedup store, survives restarts on active workflows</a:t>
             </a:r>
             <a:endParaRPr lang="en-US" sz="1200" dirty="0"/>
           </a:p>
@@ -13223,7 +12974,7 @@
                 <a:ea typeface="Calibri" pitchFamily="34" charset="-122"/>
                 <a:cs typeface="Calibri" pitchFamily="34" charset="-120"/>
               </a:rPr>
-              <a:t>Why Gmail, not Teams: Teams alerts need a Microsoft Entra client ID and secret — unavailable on personal or student accounts.</a:t>
+              <a:t>Why Gmail, not Teams: Teams alerts need a Microsoft Entra client ID and secret, unavailable on personal or student accounts.</a:t>
             </a:r>
             <a:endParaRPr lang="en-US" sz="1150" dirty="0"/>
           </a:p>
@@ -13769,7 +13520,7 @@
                           <a:ea typeface="Calibri" pitchFamily="34" charset="-122"/>
                           <a:cs typeface="Calibri" pitchFamily="34" charset="-120"/>
                         </a:rPr>
-                        <a:t>Priority 1 — Critical</a:t>
+                        <a:t>Priority 1 - Critical</a:t>
                       </a:r>
                       <a:endParaRPr lang="en-US" sz="1350" dirty="0">
                         <a:latin typeface="Calibri" charset="0"/>
@@ -14031,7 +13782,7 @@
                           <a:ea typeface="Calibri" pitchFamily="34" charset="-122"/>
                           <a:cs typeface="Calibri" pitchFamily="34" charset="-120"/>
                         </a:rPr>
-                        <a:t>Priority 2 — High</a:t>
+                        <a:t>Priority 2 - High</a:t>
                       </a:r>
                       <a:endParaRPr lang="en-US" sz="1350" dirty="0">
                         <a:latin typeface="Calibri" charset="0"/>
@@ -14672,7 +14423,7 @@
                 <a:ea typeface="Calibri" pitchFamily="34" charset="-122"/>
                 <a:cs typeface="Calibri" pitchFamily="34" charset="-120"/>
               </a:rPr>
-              <a:t>A resolved/closed incident (states 6/7/8) is excluded, so reminders stop as soon as it's closed — and start fresh if it's reopened.</a:t>
+              <a:t>A resolved/closed incident (states 6/7/8) is excluded, so reminders stop as soon as it's closed, and start fresh if it's reopened.</a:t>
             </a:r>
             <a:endParaRPr lang="en-US" sz="1150" dirty="0"/>
           </a:p>
@@ -15328,7 +15079,7 @@
                 <a:ea typeface="Calibri" pitchFamily="34" charset="-122"/>
                 <a:cs typeface="Calibri" pitchFamily="34" charset="-120"/>
               </a:rPr>
-              <a:t>TTL lock — stops overlapping runs</a:t>
+              <a:t>TTL lock stops overlapping runs</a:t>
             </a:r>
             <a:endParaRPr lang="en-US" sz="1050" dirty="0"/>
           </a:p>
@@ -16776,7 +16527,7 @@
                 <a:ea typeface="Calibri" pitchFamily="34" charset="-122"/>
                 <a:cs typeface="Calibri" pitchFamily="34" charset="-120"/>
               </a:rPr>
-              <a:t>01  —  RELIABILITY ENGINEERING</a:t>
+              <a:t>01 · RELIABILITY ENGINEERING</a:t>
             </a:r>
             <a:endParaRPr lang="en-US" sz="1400" dirty="0"/>
           </a:p>
@@ -17007,7 +16758,7 @@
                 <a:ea typeface="Calibri" pitchFamily="34" charset="-122"/>
                 <a:cs typeface="Calibri" pitchFamily="34" charset="-120"/>
               </a:rPr>
-              <a:t>A naive design emails the alert first, then records that it was sent. If the workflow crashes or the save step fails in between, the next run has no record of the send — and resends it.</a:t>
+              <a:t>A naive design emails the alert first, then records that it was sent. If the workflow crashes or the save step fails in between, the next run has no record of the send, and resends it.</a:t>
             </a:r>
             <a:endParaRPr lang="en-US" sz="1500" dirty="0"/>
           </a:p>

</xml_diff>